<commit_message>
Deck: section dividers carry the chapter number as a tone-on-tone watermark (01 to 05), title left under a short rule
</commit_message>
<xml_diff>
--- a/docs/publications/Drishti-Design-and-Evidence.pptx
+++ b/docs/publications/Drishti-Design-and-Evidence.pptx
@@ -149,13 +149,13 @@
   <p:extLst>
     <p:ext uri="{521415D9-36F7-43E2-AB2F-B90AF26B5E84}">
       <p14:sectionLst xmlns:p14="http://schemas.microsoft.com/office/powerpoint/2010/main">
-        <p14:section name="Opening" id="{96c02db4-0cc6-c589-c93e-a6b3dbfcf01f}">
+        <p14:section name="Opening" id="{8fff05ea-7e3f-edc1-6e4c-b237f484a65c}">
           <p14:sldIdLst>
             <p14:sldId id="256"/>
             <p14:sldId id="257"/>
           </p14:sldIdLst>
         </p14:section>
-        <p14:section name="1 The idea" id="{a712c8e3-2178-97ee-3172-b8604ae84330}">
+        <p14:section name="1 The idea" id="{ca601b58-0b8b-3761-3239-43cfc2554691}">
           <p14:sldIdLst>
             <p14:sldId id="258"/>
             <p14:sldId id="259"/>
@@ -171,7 +171,7 @@
             <p14:sldId id="269"/>
           </p14:sldIdLst>
         </p14:section>
-        <p14:section name="2 The product" id="{9352e20f-24e3-42ef-e003-d4d571d5bd1c}">
+        <p14:section name="2 The product" id="{426419ec-ae60-8af7-70b6-913aa38d3bca}">
           <p14:sldIdLst>
             <p14:sldId id="270"/>
             <p14:sldId id="271"/>
@@ -187,7 +187,7 @@
             <p14:sldId id="281"/>
           </p14:sldIdLst>
         </p14:section>
-        <p14:section name="3 Security" id="{ce4dddd9-208d-b13c-ccce-4a890378107e}">
+        <p14:section name="3 Security" id="{31e90070-bf08-f842-13da-c475a1110454}">
           <p14:sldIdLst>
             <p14:sldId id="282"/>
             <p14:sldId id="283"/>
@@ -197,7 +197,7 @@
             <p14:sldId id="287"/>
           </p14:sldIdLst>
         </p14:section>
-        <p14:section name="4 Evidence" id="{7e735013-be5a-282d-ee1e-eb4bc37820be}">
+        <p14:section name="4 Evidence" id="{c3cbb4b4-ca8c-870f-e402-1568eefc4f50}">
           <p14:sldIdLst>
             <p14:sldId id="288"/>
             <p14:sldId id="289"/>
@@ -208,7 +208,7 @@
             <p14:sldId id="294"/>
           </p14:sldIdLst>
         </p14:section>
-        <p14:section name="5 Where it is going" id="{14d0c23b-9cff-963d-922b-0020955d72a0}">
+        <p14:section name="5 Where it is going" id="{40493725-4708-b045-208a-8e178f7cb474}">
           <p14:sldIdLst>
             <p14:sldId id="295"/>
             <p14:sldId id="296"/>
@@ -12020,13 +12020,49 @@
       </p:grpSpPr>
       <p:sp>
         <p:nvSpPr>
-          <p:cNvPr id="2" name="Shape 0"/>
+          <p:cNvPr id="2" name="Chapter watermark"/>
+          <p:cNvSpPr txBox="1"/>
+          <p:nvPr/>
+        </p:nvSpPr>
+        <p:spPr>
+          <a:xfrm>
+            <a:off x="7589520" y="502920"/>
+            <a:ext cx="4206240" cy="3017520"/>
+          </a:xfrm>
+          <a:prstGeom prst="rect">
+            <a:avLst/>
+          </a:prstGeom>
+          <a:noFill/>
+          <a:ln/>
+        </p:spPr>
+        <p:txBody>
+          <a:bodyPr wrap="square" lIns="0" tIns="0" rIns="0" bIns="0" rtlCol="0" anchor="t"/>
+          <a:lstStyle/>
+          <a:p>
+            <a:pPr algn="r" indent="0" marL="0">
+              <a:buNone/>
+            </a:pPr>
+            <a:r>
+              <a:rPr lang="en-US" sz="16000" b="1" dirty="0">
+                <a:solidFill>
+                  <a:srgbClr val="A51C30"/>
+                </a:solidFill>
+              </a:rPr>
+              <a:t>02</a:t>
+            </a:r>
+            <a:endParaRPr lang="en-US" sz="16000" dirty="0"/>
+          </a:p>
+        </p:txBody>
+      </p:sp>
+      <p:sp>
+        <p:nvSpPr>
+          <p:cNvPr id="3" name="Shape 1"/>
           <p:cNvSpPr/>
           <p:nvPr/>
         </p:nvSpPr>
         <p:spPr>
           <a:xfrm>
-            <a:off x="1051560" y="768096"/>
+            <a:off x="822960" y="768096"/>
             <a:ext cx="512064" cy="256032"/>
           </a:xfrm>
           <a:prstGeom prst="arc">
@@ -12045,13 +12081,13 @@
       </p:sp>
       <p:sp>
         <p:nvSpPr>
-          <p:cNvPr id="3" name="Shape 1"/>
+          <p:cNvPr id="4" name="Shape 2"/>
           <p:cNvSpPr/>
           <p:nvPr/>
         </p:nvSpPr>
         <p:spPr>
           <a:xfrm>
-            <a:off x="1051560" y="914400"/>
+            <a:off x="822960" y="914400"/>
             <a:ext cx="512064" cy="256032"/>
           </a:xfrm>
           <a:prstGeom prst="arc">
@@ -12070,13 +12106,13 @@
       </p:sp>
       <p:sp>
         <p:nvSpPr>
-          <p:cNvPr id="4" name="Shape 2"/>
+          <p:cNvPr id="5" name="Shape 3"/>
           <p:cNvSpPr/>
           <p:nvPr/>
         </p:nvSpPr>
         <p:spPr>
           <a:xfrm>
-            <a:off x="1051560" y="1060704"/>
+            <a:off x="822960" y="1060704"/>
             <a:ext cx="512064" cy="256032"/>
           </a:xfrm>
           <a:prstGeom prst="arc">
@@ -12095,106 +12131,14 @@
       </p:sp>
       <p:sp>
         <p:nvSpPr>
-          <p:cNvPr id="5" name="Shape 3"/>
+          <p:cNvPr id="6" name="Shape 4"/>
           <p:cNvSpPr/>
           <p:nvPr/>
         </p:nvSpPr>
         <p:spPr>
           <a:xfrm>
-            <a:off x="5431536" y="1325880"/>
-            <a:ext cx="1325880" cy="1325880"/>
-          </a:xfrm>
-          <a:prstGeom prst="ellipse">
-            <a:avLst/>
-          </a:prstGeom>
-          <a:solidFill>
-            <a:srgbClr val="FFFFFF"/>
-          </a:solidFill>
-          <a:ln/>
-        </p:spPr>
-      </p:sp>
-      <p:sp>
-        <p:nvSpPr>
-          <p:cNvPr id="6" name="Text 4"/>
-          <p:cNvSpPr txBox="1"/>
-          <p:nvPr/>
-        </p:nvSpPr>
-        <p:spPr>
-          <a:xfrm>
-            <a:off x="5431536" y="1325880"/>
-            <a:ext cx="1325880" cy="1325880"/>
-          </a:xfrm>
-          <a:prstGeom prst="rect">
-            <a:avLst/>
-          </a:prstGeom>
-          <a:noFill/>
-          <a:ln/>
-        </p:spPr>
-        <p:txBody>
-          <a:bodyPr wrap="square" lIns="0" tIns="0" rIns="0" bIns="0" rtlCol="0" anchor="ctr"/>
-          <a:lstStyle/>
-          <a:p>
-            <a:pPr algn="ctr" indent="0" marL="0">
-              <a:buNone/>
-            </a:pPr>
-            <a:r>
-              <a:rPr lang="en-US" sz="4400" b="1" dirty="0">
-                <a:solidFill>
-                  <a:srgbClr val="8A1626"/>
-                </a:solidFill>
-              </a:rPr>
-              <a:t>2</a:t>
-            </a:r>
-            <a:endParaRPr lang="en-US" sz="4400" dirty="0"/>
-          </a:p>
-        </p:txBody>
-      </p:sp>
-      <p:sp>
-        <p:nvSpPr>
-          <p:cNvPr id="7" name="Text 5"/>
-          <p:cNvSpPr txBox="1"/>
-          <p:nvPr/>
-        </p:nvSpPr>
-        <p:spPr>
-          <a:xfrm>
-            <a:off x="1234440" y="2926080"/>
-            <a:ext cx="9720072" cy="731520"/>
-          </a:xfrm>
-          <a:prstGeom prst="rect">
-            <a:avLst/>
-          </a:prstGeom>
-          <a:noFill/>
-          <a:ln/>
-        </p:spPr>
-        <p:txBody>
-          <a:bodyPr wrap="square" lIns="0" tIns="0" rIns="0" bIns="0" rtlCol="0" anchor="ctr"/>
-          <a:lstStyle/>
-          <a:p>
-            <a:pPr algn="ctr" indent="0" marL="0">
-              <a:buNone/>
-            </a:pPr>
-            <a:r>
-              <a:rPr lang="en-US" sz="3800" b="1" dirty="0">
-                <a:solidFill>
-                  <a:srgbClr val="FFFFFF"/>
-                </a:solidFill>
-              </a:rPr>
-              <a:t>Drishti 1.18: the product</a:t>
-            </a:r>
-            <a:endParaRPr lang="en-US" sz="3800" dirty="0"/>
-          </a:p>
-        </p:txBody>
-      </p:sp>
-      <p:sp>
-        <p:nvSpPr>
-          <p:cNvPr id="8" name="Shape 6"/>
-          <p:cNvSpPr/>
-          <p:nvPr/>
-        </p:nvSpPr>
-        <p:spPr>
-          <a:xfrm>
-            <a:off x="5413248" y="3849624"/>
-            <a:ext cx="1371600" cy="36576"/>
+            <a:off x="822960" y="2788920"/>
+            <a:ext cx="2194560" cy="54864"/>
           </a:xfrm>
           <a:prstGeom prst="rect">
             <a:avLst/>
@@ -12207,14 +12151,14 @@
       </p:sp>
       <p:sp>
         <p:nvSpPr>
-          <p:cNvPr id="9" name="Text 7"/>
+          <p:cNvPr id="7" name="Text 5"/>
           <p:cNvSpPr txBox="1"/>
           <p:nvPr/>
         </p:nvSpPr>
         <p:spPr>
           <a:xfrm>
-            <a:off x="1874520" y="4069080"/>
-            <a:ext cx="8439912" cy="1097280"/>
+            <a:off x="822960" y="2971800"/>
+            <a:ext cx="10058400" cy="1097280"/>
           </a:xfrm>
           <a:prstGeom prst="rect">
             <a:avLst/>
@@ -12226,7 +12170,43 @@
           <a:bodyPr wrap="square" lIns="0" tIns="0" rIns="0" bIns="0" rtlCol="0" anchor="t"/>
           <a:lstStyle/>
           <a:p>
-            <a:pPr algn="ctr" indent="0" marL="0">
+            <a:pPr indent="0" marL="0">
+              <a:buNone/>
+            </a:pPr>
+            <a:r>
+              <a:rPr lang="en-US" sz="4000" b="1" dirty="0">
+                <a:solidFill>
+                  <a:srgbClr val="FFFFFF"/>
+                </a:solidFill>
+              </a:rPr>
+              <a:t>Drishti 1.18: the product</a:t>
+            </a:r>
+            <a:endParaRPr lang="en-US" sz="4000" dirty="0"/>
+          </a:p>
+        </p:txBody>
+      </p:sp>
+      <p:sp>
+        <p:nvSpPr>
+          <p:cNvPr id="8" name="Text 6"/>
+          <p:cNvSpPr txBox="1"/>
+          <p:nvPr/>
+        </p:nvSpPr>
+        <p:spPr>
+          <a:xfrm>
+            <a:off x="822960" y="4160520"/>
+            <a:ext cx="9601200" cy="914400"/>
+          </a:xfrm>
+          <a:prstGeom prst="rect">
+            <a:avLst/>
+          </a:prstGeom>
+          <a:noFill/>
+          <a:ln/>
+        </p:spPr>
+        <p:txBody>
+          <a:bodyPr wrap="square" lIns="0" tIns="0" rIns="0" bIns="0" rtlCol="0" anchor="t"/>
+          <a:lstStyle/>
+          <a:p>
+            <a:pPr indent="0" marL="0">
               <a:buNone/>
             </a:pPr>
             <a:r>
@@ -20369,13 +20349,49 @@
       </p:grpSpPr>
       <p:sp>
         <p:nvSpPr>
-          <p:cNvPr id="2" name="Shape 0"/>
+          <p:cNvPr id="2" name="Chapter watermark"/>
+          <p:cNvSpPr txBox="1"/>
+          <p:nvPr/>
+        </p:nvSpPr>
+        <p:spPr>
+          <a:xfrm>
+            <a:off x="7589520" y="502920"/>
+            <a:ext cx="4206240" cy="3017520"/>
+          </a:xfrm>
+          <a:prstGeom prst="rect">
+            <a:avLst/>
+          </a:prstGeom>
+          <a:noFill/>
+          <a:ln/>
+        </p:spPr>
+        <p:txBody>
+          <a:bodyPr wrap="square" lIns="0" tIns="0" rIns="0" bIns="0" rtlCol="0" anchor="t"/>
+          <a:lstStyle/>
+          <a:p>
+            <a:pPr algn="r" indent="0" marL="0">
+              <a:buNone/>
+            </a:pPr>
+            <a:r>
+              <a:rPr lang="en-US" sz="16000" b="1" dirty="0">
+                <a:solidFill>
+                  <a:srgbClr val="A51C30"/>
+                </a:solidFill>
+              </a:rPr>
+              <a:t>03</a:t>
+            </a:r>
+            <a:endParaRPr lang="en-US" sz="16000" dirty="0"/>
+          </a:p>
+        </p:txBody>
+      </p:sp>
+      <p:sp>
+        <p:nvSpPr>
+          <p:cNvPr id="3" name="Shape 1"/>
           <p:cNvSpPr/>
           <p:nvPr/>
         </p:nvSpPr>
         <p:spPr>
           <a:xfrm>
-            <a:off x="1051560" y="768096"/>
+            <a:off x="822960" y="768096"/>
             <a:ext cx="512064" cy="256032"/>
           </a:xfrm>
           <a:prstGeom prst="arc">
@@ -20394,13 +20410,13 @@
       </p:sp>
       <p:sp>
         <p:nvSpPr>
-          <p:cNvPr id="3" name="Shape 1"/>
+          <p:cNvPr id="4" name="Shape 2"/>
           <p:cNvSpPr/>
           <p:nvPr/>
         </p:nvSpPr>
         <p:spPr>
           <a:xfrm>
-            <a:off x="1051560" y="914400"/>
+            <a:off x="822960" y="914400"/>
             <a:ext cx="512064" cy="256032"/>
           </a:xfrm>
           <a:prstGeom prst="arc">
@@ -20419,13 +20435,13 @@
       </p:sp>
       <p:sp>
         <p:nvSpPr>
-          <p:cNvPr id="4" name="Shape 2"/>
+          <p:cNvPr id="5" name="Shape 3"/>
           <p:cNvSpPr/>
           <p:nvPr/>
         </p:nvSpPr>
         <p:spPr>
           <a:xfrm>
-            <a:off x="1051560" y="1060704"/>
+            <a:off x="822960" y="1060704"/>
             <a:ext cx="512064" cy="256032"/>
           </a:xfrm>
           <a:prstGeom prst="arc">
@@ -20444,106 +20460,14 @@
       </p:sp>
       <p:sp>
         <p:nvSpPr>
-          <p:cNvPr id="5" name="Shape 3"/>
+          <p:cNvPr id="6" name="Shape 4"/>
           <p:cNvSpPr/>
           <p:nvPr/>
         </p:nvSpPr>
         <p:spPr>
           <a:xfrm>
-            <a:off x="5431536" y="1325880"/>
-            <a:ext cx="1325880" cy="1325880"/>
-          </a:xfrm>
-          <a:prstGeom prst="ellipse">
-            <a:avLst/>
-          </a:prstGeom>
-          <a:solidFill>
-            <a:srgbClr val="FFFFFF"/>
-          </a:solidFill>
-          <a:ln/>
-        </p:spPr>
-      </p:sp>
-      <p:sp>
-        <p:nvSpPr>
-          <p:cNvPr id="6" name="Text 4"/>
-          <p:cNvSpPr txBox="1"/>
-          <p:nvPr/>
-        </p:nvSpPr>
-        <p:spPr>
-          <a:xfrm>
-            <a:off x="5431536" y="1325880"/>
-            <a:ext cx="1325880" cy="1325880"/>
-          </a:xfrm>
-          <a:prstGeom prst="rect">
-            <a:avLst/>
-          </a:prstGeom>
-          <a:noFill/>
-          <a:ln/>
-        </p:spPr>
-        <p:txBody>
-          <a:bodyPr wrap="square" lIns="0" tIns="0" rIns="0" bIns="0" rtlCol="0" anchor="ctr"/>
-          <a:lstStyle/>
-          <a:p>
-            <a:pPr algn="ctr" indent="0" marL="0">
-              <a:buNone/>
-            </a:pPr>
-            <a:r>
-              <a:rPr lang="en-US" sz="4400" b="1" dirty="0">
-                <a:solidFill>
-                  <a:srgbClr val="8A1626"/>
-                </a:solidFill>
-              </a:rPr>
-              <a:t>3</a:t>
-            </a:r>
-            <a:endParaRPr lang="en-US" sz="4400" dirty="0"/>
-          </a:p>
-        </p:txBody>
-      </p:sp>
-      <p:sp>
-        <p:nvSpPr>
-          <p:cNvPr id="7" name="Text 5"/>
-          <p:cNvSpPr txBox="1"/>
-          <p:nvPr/>
-        </p:nvSpPr>
-        <p:spPr>
-          <a:xfrm>
-            <a:off x="1234440" y="2926080"/>
-            <a:ext cx="9720072" cy="731520"/>
-          </a:xfrm>
-          <a:prstGeom prst="rect">
-            <a:avLst/>
-          </a:prstGeom>
-          <a:noFill/>
-          <a:ln/>
-        </p:spPr>
-        <p:txBody>
-          <a:bodyPr wrap="square" lIns="0" tIns="0" rIns="0" bIns="0" rtlCol="0" anchor="ctr"/>
-          <a:lstStyle/>
-          <a:p>
-            <a:pPr algn="ctr" indent="0" marL="0">
-              <a:buNone/>
-            </a:pPr>
-            <a:r>
-              <a:rPr lang="en-US" sz="3800" b="1" dirty="0">
-                <a:solidFill>
-                  <a:srgbClr val="FFFFFF"/>
-                </a:solidFill>
-              </a:rPr>
-              <a:t>Security, drawn as flows</a:t>
-            </a:r>
-            <a:endParaRPr lang="en-US" sz="3800" dirty="0"/>
-          </a:p>
-        </p:txBody>
-      </p:sp>
-      <p:sp>
-        <p:nvSpPr>
-          <p:cNvPr id="8" name="Shape 6"/>
-          <p:cNvSpPr/>
-          <p:nvPr/>
-        </p:nvSpPr>
-        <p:spPr>
-          <a:xfrm>
-            <a:off x="5413248" y="3849624"/>
-            <a:ext cx="1371600" cy="36576"/>
+            <a:off x="822960" y="2788920"/>
+            <a:ext cx="2194560" cy="54864"/>
           </a:xfrm>
           <a:prstGeom prst="rect">
             <a:avLst/>
@@ -20556,14 +20480,14 @@
       </p:sp>
       <p:sp>
         <p:nvSpPr>
-          <p:cNvPr id="9" name="Text 7"/>
+          <p:cNvPr id="7" name="Text 5"/>
           <p:cNvSpPr txBox="1"/>
           <p:nvPr/>
         </p:nvSpPr>
         <p:spPr>
           <a:xfrm>
-            <a:off x="1874520" y="4069080"/>
-            <a:ext cx="8439912" cy="1097280"/>
+            <a:off x="822960" y="2971800"/>
+            <a:ext cx="10058400" cy="1097280"/>
           </a:xfrm>
           <a:prstGeom prst="rect">
             <a:avLst/>
@@ -20575,7 +20499,43 @@
           <a:bodyPr wrap="square" lIns="0" tIns="0" rIns="0" bIns="0" rtlCol="0" anchor="t"/>
           <a:lstStyle/>
           <a:p>
-            <a:pPr algn="ctr" indent="0" marL="0">
+            <a:pPr indent="0" marL="0">
+              <a:buNone/>
+            </a:pPr>
+            <a:r>
+              <a:rPr lang="en-US" sz="4000" b="1" dirty="0">
+                <a:solidFill>
+                  <a:srgbClr val="FFFFFF"/>
+                </a:solidFill>
+              </a:rPr>
+              <a:t>Security, drawn as flows</a:t>
+            </a:r>
+            <a:endParaRPr lang="en-US" sz="4000" dirty="0"/>
+          </a:p>
+        </p:txBody>
+      </p:sp>
+      <p:sp>
+        <p:nvSpPr>
+          <p:cNvPr id="8" name="Text 6"/>
+          <p:cNvSpPr txBox="1"/>
+          <p:nvPr/>
+        </p:nvSpPr>
+        <p:spPr>
+          <a:xfrm>
+            <a:off x="822960" y="4160520"/>
+            <a:ext cx="9601200" cy="914400"/>
+          </a:xfrm>
+          <a:prstGeom prst="rect">
+            <a:avLst/>
+          </a:prstGeom>
+          <a:noFill/>
+          <a:ln/>
+        </p:spPr>
+        <p:txBody>
+          <a:bodyPr wrap="square" lIns="0" tIns="0" rIns="0" bIns="0" rtlCol="0" anchor="t"/>
+          <a:lstStyle/>
+          <a:p>
+            <a:pPr indent="0" marL="0">
               <a:buNone/>
             </a:pPr>
             <a:r>
@@ -22133,13 +22093,49 @@
       </p:grpSpPr>
       <p:sp>
         <p:nvSpPr>
-          <p:cNvPr id="2" name="Shape 0"/>
+          <p:cNvPr id="2" name="Chapter watermark"/>
+          <p:cNvSpPr txBox="1"/>
+          <p:nvPr/>
+        </p:nvSpPr>
+        <p:spPr>
+          <a:xfrm>
+            <a:off x="7589520" y="502920"/>
+            <a:ext cx="4206240" cy="3017520"/>
+          </a:xfrm>
+          <a:prstGeom prst="rect">
+            <a:avLst/>
+          </a:prstGeom>
+          <a:noFill/>
+          <a:ln/>
+        </p:spPr>
+        <p:txBody>
+          <a:bodyPr wrap="square" lIns="0" tIns="0" rIns="0" bIns="0" rtlCol="0" anchor="t"/>
+          <a:lstStyle/>
+          <a:p>
+            <a:pPr algn="r" indent="0" marL="0">
+              <a:buNone/>
+            </a:pPr>
+            <a:r>
+              <a:rPr lang="en-US" sz="16000" b="1" dirty="0">
+                <a:solidFill>
+                  <a:srgbClr val="A51C30"/>
+                </a:solidFill>
+              </a:rPr>
+              <a:t>01</a:t>
+            </a:r>
+            <a:endParaRPr lang="en-US" sz="16000" dirty="0"/>
+          </a:p>
+        </p:txBody>
+      </p:sp>
+      <p:sp>
+        <p:nvSpPr>
+          <p:cNvPr id="3" name="Shape 1"/>
           <p:cNvSpPr/>
           <p:nvPr/>
         </p:nvSpPr>
         <p:spPr>
           <a:xfrm>
-            <a:off x="1051560" y="768096"/>
+            <a:off x="822960" y="768096"/>
             <a:ext cx="512064" cy="256032"/>
           </a:xfrm>
           <a:prstGeom prst="arc">
@@ -22158,13 +22154,13 @@
       </p:sp>
       <p:sp>
         <p:nvSpPr>
-          <p:cNvPr id="3" name="Shape 1"/>
+          <p:cNvPr id="4" name="Shape 2"/>
           <p:cNvSpPr/>
           <p:nvPr/>
         </p:nvSpPr>
         <p:spPr>
           <a:xfrm>
-            <a:off x="1051560" y="914400"/>
+            <a:off x="822960" y="914400"/>
             <a:ext cx="512064" cy="256032"/>
           </a:xfrm>
           <a:prstGeom prst="arc">
@@ -22183,13 +22179,13 @@
       </p:sp>
       <p:sp>
         <p:nvSpPr>
-          <p:cNvPr id="4" name="Shape 2"/>
+          <p:cNvPr id="5" name="Shape 3"/>
           <p:cNvSpPr/>
           <p:nvPr/>
         </p:nvSpPr>
         <p:spPr>
           <a:xfrm>
-            <a:off x="1051560" y="1060704"/>
+            <a:off x="822960" y="1060704"/>
             <a:ext cx="512064" cy="256032"/>
           </a:xfrm>
           <a:prstGeom prst="arc">
@@ -22208,106 +22204,14 @@
       </p:sp>
       <p:sp>
         <p:nvSpPr>
-          <p:cNvPr id="5" name="Shape 3"/>
+          <p:cNvPr id="6" name="Shape 4"/>
           <p:cNvSpPr/>
           <p:nvPr/>
         </p:nvSpPr>
         <p:spPr>
           <a:xfrm>
-            <a:off x="5431536" y="1325880"/>
-            <a:ext cx="1325880" cy="1325880"/>
-          </a:xfrm>
-          <a:prstGeom prst="ellipse">
-            <a:avLst/>
-          </a:prstGeom>
-          <a:solidFill>
-            <a:srgbClr val="FFFFFF"/>
-          </a:solidFill>
-          <a:ln/>
-        </p:spPr>
-      </p:sp>
-      <p:sp>
-        <p:nvSpPr>
-          <p:cNvPr id="6" name="Text 4"/>
-          <p:cNvSpPr txBox="1"/>
-          <p:nvPr/>
-        </p:nvSpPr>
-        <p:spPr>
-          <a:xfrm>
-            <a:off x="5431536" y="1325880"/>
-            <a:ext cx="1325880" cy="1325880"/>
-          </a:xfrm>
-          <a:prstGeom prst="rect">
-            <a:avLst/>
-          </a:prstGeom>
-          <a:noFill/>
-          <a:ln/>
-        </p:spPr>
-        <p:txBody>
-          <a:bodyPr wrap="square" lIns="0" tIns="0" rIns="0" bIns="0" rtlCol="0" anchor="ctr"/>
-          <a:lstStyle/>
-          <a:p>
-            <a:pPr algn="ctr" indent="0" marL="0">
-              <a:buNone/>
-            </a:pPr>
-            <a:r>
-              <a:rPr lang="en-US" sz="4400" b="1" dirty="0">
-                <a:solidFill>
-                  <a:srgbClr val="8A1626"/>
-                </a:solidFill>
-              </a:rPr>
-              <a:t>1</a:t>
-            </a:r>
-            <a:endParaRPr lang="en-US" sz="4400" dirty="0"/>
-          </a:p>
-        </p:txBody>
-      </p:sp>
-      <p:sp>
-        <p:nvSpPr>
-          <p:cNvPr id="7" name="Text 5"/>
-          <p:cNvSpPr txBox="1"/>
-          <p:nvPr/>
-        </p:nvSpPr>
-        <p:spPr>
-          <a:xfrm>
-            <a:off x="1234440" y="2926080"/>
-            <a:ext cx="9720072" cy="731520"/>
-          </a:xfrm>
-          <a:prstGeom prst="rect">
-            <a:avLst/>
-          </a:prstGeom>
-          <a:noFill/>
-          <a:ln/>
-        </p:spPr>
-        <p:txBody>
-          <a:bodyPr wrap="square" lIns="0" tIns="0" rIns="0" bIns="0" rtlCol="0" anchor="ctr"/>
-          <a:lstStyle/>
-          <a:p>
-            <a:pPr algn="ctr" indent="0" marL="0">
-              <a:buNone/>
-            </a:pPr>
-            <a:r>
-              <a:rPr lang="en-US" sz="3800" b="1" dirty="0">
-                <a:solidFill>
-                  <a:srgbClr val="FFFFFF"/>
-                </a:solidFill>
-              </a:rPr>
-              <a:t>The idea: a screen is a paragraph</a:t>
-            </a:r>
-            <a:endParaRPr lang="en-US" sz="3800" dirty="0"/>
-          </a:p>
-        </p:txBody>
-      </p:sp>
-      <p:sp>
-        <p:nvSpPr>
-          <p:cNvPr id="8" name="Shape 6"/>
-          <p:cNvSpPr/>
-          <p:nvPr/>
-        </p:nvSpPr>
-        <p:spPr>
-          <a:xfrm>
-            <a:off x="5413248" y="3849624"/>
-            <a:ext cx="1371600" cy="36576"/>
+            <a:off x="822960" y="2788920"/>
+            <a:ext cx="2194560" cy="54864"/>
           </a:xfrm>
           <a:prstGeom prst="rect">
             <a:avLst/>
@@ -22320,14 +22224,14 @@
       </p:sp>
       <p:sp>
         <p:nvSpPr>
-          <p:cNvPr id="9" name="Text 7"/>
+          <p:cNvPr id="7" name="Text 5"/>
           <p:cNvSpPr txBox="1"/>
           <p:nvPr/>
         </p:nvSpPr>
         <p:spPr>
           <a:xfrm>
-            <a:off x="1874520" y="4069080"/>
-            <a:ext cx="8439912" cy="1097280"/>
+            <a:off x="822960" y="2971800"/>
+            <a:ext cx="10058400" cy="1097280"/>
           </a:xfrm>
           <a:prstGeom prst="rect">
             <a:avLst/>
@@ -22339,7 +22243,43 @@
           <a:bodyPr wrap="square" lIns="0" tIns="0" rIns="0" bIns="0" rtlCol="0" anchor="t"/>
           <a:lstStyle/>
           <a:p>
-            <a:pPr algn="ctr" indent="0" marL="0">
+            <a:pPr indent="0" marL="0">
+              <a:buNone/>
+            </a:pPr>
+            <a:r>
+              <a:rPr lang="en-US" sz="4000" b="1" dirty="0">
+                <a:solidFill>
+                  <a:srgbClr val="FFFFFF"/>
+                </a:solidFill>
+              </a:rPr>
+              <a:t>The idea: a screen is a paragraph</a:t>
+            </a:r>
+            <a:endParaRPr lang="en-US" sz="4000" dirty="0"/>
+          </a:p>
+        </p:txBody>
+      </p:sp>
+      <p:sp>
+        <p:nvSpPr>
+          <p:cNvPr id="8" name="Text 6"/>
+          <p:cNvSpPr txBox="1"/>
+          <p:nvPr/>
+        </p:nvSpPr>
+        <p:spPr>
+          <a:xfrm>
+            <a:off x="822960" y="4160520"/>
+            <a:ext cx="9601200" cy="914400"/>
+          </a:xfrm>
+          <a:prstGeom prst="rect">
+            <a:avLst/>
+          </a:prstGeom>
+          <a:noFill/>
+          <a:ln/>
+        </p:spPr>
+        <p:txBody>
+          <a:bodyPr wrap="square" lIns="0" tIns="0" rIns="0" bIns="0" rtlCol="0" anchor="t"/>
+          <a:lstStyle/>
+          <a:p>
+            <a:pPr indent="0" marL="0">
               <a:buNone/>
             </a:pPr>
             <a:r>
@@ -25468,13 +25408,49 @@
       </p:grpSpPr>
       <p:sp>
         <p:nvSpPr>
-          <p:cNvPr id="2" name="Shape 0"/>
+          <p:cNvPr id="2" name="Chapter watermark"/>
+          <p:cNvSpPr txBox="1"/>
+          <p:nvPr/>
+        </p:nvSpPr>
+        <p:spPr>
+          <a:xfrm>
+            <a:off x="7589520" y="502920"/>
+            <a:ext cx="4206240" cy="3017520"/>
+          </a:xfrm>
+          <a:prstGeom prst="rect">
+            <a:avLst/>
+          </a:prstGeom>
+          <a:noFill/>
+          <a:ln/>
+        </p:spPr>
+        <p:txBody>
+          <a:bodyPr wrap="square" lIns="0" tIns="0" rIns="0" bIns="0" rtlCol="0" anchor="t"/>
+          <a:lstStyle/>
+          <a:p>
+            <a:pPr algn="r" indent="0" marL="0">
+              <a:buNone/>
+            </a:pPr>
+            <a:r>
+              <a:rPr lang="en-US" sz="16000" b="1" dirty="0">
+                <a:solidFill>
+                  <a:srgbClr val="A51C30"/>
+                </a:solidFill>
+              </a:rPr>
+              <a:t>04</a:t>
+            </a:r>
+            <a:endParaRPr lang="en-US" sz="16000" dirty="0"/>
+          </a:p>
+        </p:txBody>
+      </p:sp>
+      <p:sp>
+        <p:nvSpPr>
+          <p:cNvPr id="3" name="Shape 1"/>
           <p:cNvSpPr/>
           <p:nvPr/>
         </p:nvSpPr>
         <p:spPr>
           <a:xfrm>
-            <a:off x="1051560" y="768096"/>
+            <a:off x="822960" y="768096"/>
             <a:ext cx="512064" cy="256032"/>
           </a:xfrm>
           <a:prstGeom prst="arc">
@@ -25493,13 +25469,13 @@
       </p:sp>
       <p:sp>
         <p:nvSpPr>
-          <p:cNvPr id="3" name="Shape 1"/>
+          <p:cNvPr id="4" name="Shape 2"/>
           <p:cNvSpPr/>
           <p:nvPr/>
         </p:nvSpPr>
         <p:spPr>
           <a:xfrm>
-            <a:off x="1051560" y="914400"/>
+            <a:off x="822960" y="914400"/>
             <a:ext cx="512064" cy="256032"/>
           </a:xfrm>
           <a:prstGeom prst="arc">
@@ -25518,13 +25494,13 @@
       </p:sp>
       <p:sp>
         <p:nvSpPr>
-          <p:cNvPr id="4" name="Shape 2"/>
+          <p:cNvPr id="5" name="Shape 3"/>
           <p:cNvSpPr/>
           <p:nvPr/>
         </p:nvSpPr>
         <p:spPr>
           <a:xfrm>
-            <a:off x="1051560" y="1060704"/>
+            <a:off x="822960" y="1060704"/>
             <a:ext cx="512064" cy="256032"/>
           </a:xfrm>
           <a:prstGeom prst="arc">
@@ -25543,106 +25519,14 @@
       </p:sp>
       <p:sp>
         <p:nvSpPr>
-          <p:cNvPr id="5" name="Shape 3"/>
+          <p:cNvPr id="6" name="Shape 4"/>
           <p:cNvSpPr/>
           <p:nvPr/>
         </p:nvSpPr>
         <p:spPr>
           <a:xfrm>
-            <a:off x="5431536" y="1325880"/>
-            <a:ext cx="1325880" cy="1325880"/>
-          </a:xfrm>
-          <a:prstGeom prst="ellipse">
-            <a:avLst/>
-          </a:prstGeom>
-          <a:solidFill>
-            <a:srgbClr val="FFFFFF"/>
-          </a:solidFill>
-          <a:ln/>
-        </p:spPr>
-      </p:sp>
-      <p:sp>
-        <p:nvSpPr>
-          <p:cNvPr id="6" name="Text 4"/>
-          <p:cNvSpPr txBox="1"/>
-          <p:nvPr/>
-        </p:nvSpPr>
-        <p:spPr>
-          <a:xfrm>
-            <a:off x="5431536" y="1325880"/>
-            <a:ext cx="1325880" cy="1325880"/>
-          </a:xfrm>
-          <a:prstGeom prst="rect">
-            <a:avLst/>
-          </a:prstGeom>
-          <a:noFill/>
-          <a:ln/>
-        </p:spPr>
-        <p:txBody>
-          <a:bodyPr wrap="square" lIns="0" tIns="0" rIns="0" bIns="0" rtlCol="0" anchor="ctr"/>
-          <a:lstStyle/>
-          <a:p>
-            <a:pPr algn="ctr" indent="0" marL="0">
-              <a:buNone/>
-            </a:pPr>
-            <a:r>
-              <a:rPr lang="en-US" sz="4400" b="1" dirty="0">
-                <a:solidFill>
-                  <a:srgbClr val="8A1626"/>
-                </a:solidFill>
-              </a:rPr>
-              <a:t>4</a:t>
-            </a:r>
-            <a:endParaRPr lang="en-US" sz="4400" dirty="0"/>
-          </a:p>
-        </p:txBody>
-      </p:sp>
-      <p:sp>
-        <p:nvSpPr>
-          <p:cNvPr id="7" name="Text 5"/>
-          <p:cNvSpPr txBox="1"/>
-          <p:nvPr/>
-        </p:nvSpPr>
-        <p:spPr>
-          <a:xfrm>
-            <a:off x="1234440" y="2926080"/>
-            <a:ext cx="9720072" cy="731520"/>
-          </a:xfrm>
-          <a:prstGeom prst="rect">
-            <a:avLst/>
-          </a:prstGeom>
-          <a:noFill/>
-          <a:ln/>
-        </p:spPr>
-        <p:txBody>
-          <a:bodyPr wrap="square" lIns="0" tIns="0" rIns="0" bIns="0" rtlCol="0" anchor="ctr"/>
-          <a:lstStyle/>
-          <a:p>
-            <a:pPr algn="ctr" indent="0" marL="0">
-              <a:buNone/>
-            </a:pPr>
-            <a:r>
-              <a:rPr lang="en-US" sz="3800" b="1" dirty="0">
-                <a:solidFill>
-                  <a:srgbClr val="FFFFFF"/>
-                </a:solidFill>
-              </a:rPr>
-              <a:t>Evidence, by the numbers</a:t>
-            </a:r>
-            <a:endParaRPr lang="en-US" sz="3800" dirty="0"/>
-          </a:p>
-        </p:txBody>
-      </p:sp>
-      <p:sp>
-        <p:nvSpPr>
-          <p:cNvPr id="8" name="Shape 6"/>
-          <p:cNvSpPr/>
-          <p:nvPr/>
-        </p:nvSpPr>
-        <p:spPr>
-          <a:xfrm>
-            <a:off x="5413248" y="3849624"/>
-            <a:ext cx="1371600" cy="36576"/>
+            <a:off x="822960" y="2788920"/>
+            <a:ext cx="2194560" cy="54864"/>
           </a:xfrm>
           <a:prstGeom prst="rect">
             <a:avLst/>
@@ -25655,14 +25539,14 @@
       </p:sp>
       <p:sp>
         <p:nvSpPr>
-          <p:cNvPr id="9" name="Text 7"/>
+          <p:cNvPr id="7" name="Text 5"/>
           <p:cNvSpPr txBox="1"/>
           <p:nvPr/>
         </p:nvSpPr>
         <p:spPr>
           <a:xfrm>
-            <a:off x="1874520" y="4069080"/>
-            <a:ext cx="8439912" cy="1097280"/>
+            <a:off x="822960" y="2971800"/>
+            <a:ext cx="10058400" cy="1097280"/>
           </a:xfrm>
           <a:prstGeom prst="rect">
             <a:avLst/>
@@ -25674,7 +25558,43 @@
           <a:bodyPr wrap="square" lIns="0" tIns="0" rIns="0" bIns="0" rtlCol="0" anchor="t"/>
           <a:lstStyle/>
           <a:p>
-            <a:pPr algn="ctr" indent="0" marL="0">
+            <a:pPr indent="0" marL="0">
+              <a:buNone/>
+            </a:pPr>
+            <a:r>
+              <a:rPr lang="en-US" sz="4000" b="1" dirty="0">
+                <a:solidFill>
+                  <a:srgbClr val="FFFFFF"/>
+                </a:solidFill>
+              </a:rPr>
+              <a:t>Evidence, by the numbers</a:t>
+            </a:r>
+            <a:endParaRPr lang="en-US" sz="4000" dirty="0"/>
+          </a:p>
+        </p:txBody>
+      </p:sp>
+      <p:sp>
+        <p:nvSpPr>
+          <p:cNvPr id="8" name="Text 6"/>
+          <p:cNvSpPr txBox="1"/>
+          <p:nvPr/>
+        </p:nvSpPr>
+        <p:spPr>
+          <a:xfrm>
+            <a:off x="822960" y="4160520"/>
+            <a:ext cx="9601200" cy="914400"/>
+          </a:xfrm>
+          <a:prstGeom prst="rect">
+            <a:avLst/>
+          </a:prstGeom>
+          <a:noFill/>
+          <a:ln/>
+        </p:spPr>
+        <p:txBody>
+          <a:bodyPr wrap="square" lIns="0" tIns="0" rIns="0" bIns="0" rtlCol="0" anchor="t"/>
+          <a:lstStyle/>
+          <a:p>
+            <a:pPr indent="0" marL="0">
               <a:buNone/>
             </a:pPr>
             <a:r>
@@ -34053,13 +33973,49 @@
       </p:grpSpPr>
       <p:sp>
         <p:nvSpPr>
-          <p:cNvPr id="2" name="Shape 0"/>
+          <p:cNvPr id="2" name="Chapter watermark"/>
+          <p:cNvSpPr txBox="1"/>
+          <p:nvPr/>
+        </p:nvSpPr>
+        <p:spPr>
+          <a:xfrm>
+            <a:off x="7589520" y="502920"/>
+            <a:ext cx="4206240" cy="3017520"/>
+          </a:xfrm>
+          <a:prstGeom prst="rect">
+            <a:avLst/>
+          </a:prstGeom>
+          <a:noFill/>
+          <a:ln/>
+        </p:spPr>
+        <p:txBody>
+          <a:bodyPr wrap="square" lIns="0" tIns="0" rIns="0" bIns="0" rtlCol="0" anchor="t"/>
+          <a:lstStyle/>
+          <a:p>
+            <a:pPr algn="r" indent="0" marL="0">
+              <a:buNone/>
+            </a:pPr>
+            <a:r>
+              <a:rPr lang="en-US" sz="16000" b="1" dirty="0">
+                <a:solidFill>
+                  <a:srgbClr val="A51C30"/>
+                </a:solidFill>
+              </a:rPr>
+              <a:t>05</a:t>
+            </a:r>
+            <a:endParaRPr lang="en-US" sz="16000" dirty="0"/>
+          </a:p>
+        </p:txBody>
+      </p:sp>
+      <p:sp>
+        <p:nvSpPr>
+          <p:cNvPr id="3" name="Shape 1"/>
           <p:cNvSpPr/>
           <p:nvPr/>
         </p:nvSpPr>
         <p:spPr>
           <a:xfrm>
-            <a:off x="1051560" y="768096"/>
+            <a:off x="822960" y="768096"/>
             <a:ext cx="512064" cy="256032"/>
           </a:xfrm>
           <a:prstGeom prst="arc">
@@ -34078,13 +34034,13 @@
       </p:sp>
       <p:sp>
         <p:nvSpPr>
-          <p:cNvPr id="3" name="Shape 1"/>
+          <p:cNvPr id="4" name="Shape 2"/>
           <p:cNvSpPr/>
           <p:nvPr/>
         </p:nvSpPr>
         <p:spPr>
           <a:xfrm>
-            <a:off x="1051560" y="914400"/>
+            <a:off x="822960" y="914400"/>
             <a:ext cx="512064" cy="256032"/>
           </a:xfrm>
           <a:prstGeom prst="arc">
@@ -34103,13 +34059,13 @@
       </p:sp>
       <p:sp>
         <p:nvSpPr>
-          <p:cNvPr id="4" name="Shape 2"/>
+          <p:cNvPr id="5" name="Shape 3"/>
           <p:cNvSpPr/>
           <p:nvPr/>
         </p:nvSpPr>
         <p:spPr>
           <a:xfrm>
-            <a:off x="1051560" y="1060704"/>
+            <a:off x="822960" y="1060704"/>
             <a:ext cx="512064" cy="256032"/>
           </a:xfrm>
           <a:prstGeom prst="arc">
@@ -34128,106 +34084,14 @@
       </p:sp>
       <p:sp>
         <p:nvSpPr>
-          <p:cNvPr id="5" name="Shape 3"/>
+          <p:cNvPr id="6" name="Shape 4"/>
           <p:cNvSpPr/>
           <p:nvPr/>
         </p:nvSpPr>
         <p:spPr>
           <a:xfrm>
-            <a:off x="5431536" y="1325880"/>
-            <a:ext cx="1325880" cy="1325880"/>
-          </a:xfrm>
-          <a:prstGeom prst="ellipse">
-            <a:avLst/>
-          </a:prstGeom>
-          <a:solidFill>
-            <a:srgbClr val="FFFFFF"/>
-          </a:solidFill>
-          <a:ln/>
-        </p:spPr>
-      </p:sp>
-      <p:sp>
-        <p:nvSpPr>
-          <p:cNvPr id="6" name="Text 4"/>
-          <p:cNvSpPr txBox="1"/>
-          <p:nvPr/>
-        </p:nvSpPr>
-        <p:spPr>
-          <a:xfrm>
-            <a:off x="5431536" y="1325880"/>
-            <a:ext cx="1325880" cy="1325880"/>
-          </a:xfrm>
-          <a:prstGeom prst="rect">
-            <a:avLst/>
-          </a:prstGeom>
-          <a:noFill/>
-          <a:ln/>
-        </p:spPr>
-        <p:txBody>
-          <a:bodyPr wrap="square" lIns="0" tIns="0" rIns="0" bIns="0" rtlCol="0" anchor="ctr"/>
-          <a:lstStyle/>
-          <a:p>
-            <a:pPr algn="ctr" indent="0" marL="0">
-              <a:buNone/>
-            </a:pPr>
-            <a:r>
-              <a:rPr lang="en-US" sz="4400" b="1" dirty="0">
-                <a:solidFill>
-                  <a:srgbClr val="8A1626"/>
-                </a:solidFill>
-              </a:rPr>
-              <a:t>5</a:t>
-            </a:r>
-            <a:endParaRPr lang="en-US" sz="4400" dirty="0"/>
-          </a:p>
-        </p:txBody>
-      </p:sp>
-      <p:sp>
-        <p:nvSpPr>
-          <p:cNvPr id="7" name="Text 5"/>
-          <p:cNvSpPr txBox="1"/>
-          <p:nvPr/>
-        </p:nvSpPr>
-        <p:spPr>
-          <a:xfrm>
-            <a:off x="1234440" y="2926080"/>
-            <a:ext cx="9720072" cy="731520"/>
-          </a:xfrm>
-          <a:prstGeom prst="rect">
-            <a:avLst/>
-          </a:prstGeom>
-          <a:noFill/>
-          <a:ln/>
-        </p:spPr>
-        <p:txBody>
-          <a:bodyPr wrap="square" lIns="0" tIns="0" rIns="0" bIns="0" rtlCol="0" anchor="ctr"/>
-          <a:lstStyle/>
-          <a:p>
-            <a:pPr algn="ctr" indent="0" marL="0">
-              <a:buNone/>
-            </a:pPr>
-            <a:r>
-              <a:rPr lang="en-US" sz="3800" b="1" dirty="0">
-                <a:solidFill>
-                  <a:srgbClr val="FFFFFF"/>
-                </a:solidFill>
-              </a:rPr>
-              <a:t>Where it is going</a:t>
-            </a:r>
-            <a:endParaRPr lang="en-US" sz="3800" dirty="0"/>
-          </a:p>
-        </p:txBody>
-      </p:sp>
-      <p:sp>
-        <p:nvSpPr>
-          <p:cNvPr id="8" name="Shape 6"/>
-          <p:cNvSpPr/>
-          <p:nvPr/>
-        </p:nvSpPr>
-        <p:spPr>
-          <a:xfrm>
-            <a:off x="5413248" y="3849624"/>
-            <a:ext cx="1371600" cy="36576"/>
+            <a:off x="822960" y="2788920"/>
+            <a:ext cx="2194560" cy="54864"/>
           </a:xfrm>
           <a:prstGeom prst="rect">
             <a:avLst/>
@@ -34240,14 +34104,14 @@
       </p:sp>
       <p:sp>
         <p:nvSpPr>
-          <p:cNvPr id="9" name="Text 7"/>
+          <p:cNvPr id="7" name="Text 5"/>
           <p:cNvSpPr txBox="1"/>
           <p:nvPr/>
         </p:nvSpPr>
         <p:spPr>
           <a:xfrm>
-            <a:off x="1874520" y="4069080"/>
-            <a:ext cx="8439912" cy="1097280"/>
+            <a:off x="822960" y="2971800"/>
+            <a:ext cx="10058400" cy="1097280"/>
           </a:xfrm>
           <a:prstGeom prst="rect">
             <a:avLst/>
@@ -34259,7 +34123,43 @@
           <a:bodyPr wrap="square" lIns="0" tIns="0" rIns="0" bIns="0" rtlCol="0" anchor="t"/>
           <a:lstStyle/>
           <a:p>
-            <a:pPr algn="ctr" indent="0" marL="0">
+            <a:pPr indent="0" marL="0">
+              <a:buNone/>
+            </a:pPr>
+            <a:r>
+              <a:rPr lang="en-US" sz="4000" b="1" dirty="0">
+                <a:solidFill>
+                  <a:srgbClr val="FFFFFF"/>
+                </a:solidFill>
+              </a:rPr>
+              <a:t>Where it is going</a:t>
+            </a:r>
+            <a:endParaRPr lang="en-US" sz="4000" dirty="0"/>
+          </a:p>
+        </p:txBody>
+      </p:sp>
+      <p:sp>
+        <p:nvSpPr>
+          <p:cNvPr id="8" name="Text 6"/>
+          <p:cNvSpPr txBox="1"/>
+          <p:nvPr/>
+        </p:nvSpPr>
+        <p:spPr>
+          <a:xfrm>
+            <a:off x="822960" y="4160520"/>
+            <a:ext cx="9601200" cy="914400"/>
+          </a:xfrm>
+          <a:prstGeom prst="rect">
+            <a:avLst/>
+          </a:prstGeom>
+          <a:noFill/>
+          <a:ln/>
+        </p:spPr>
+        <p:txBody>
+          <a:bodyPr wrap="square" lIns="0" tIns="0" rIns="0" bIns="0" rtlCol="0" anchor="t"/>
+          <a:lstStyle/>
+          <a:p>
+            <a:pPr indent="0" marL="0">
               <a:buNone/>
             </a:pPr>
             <a:r>

</xml_diff>

<commit_message>
Deck: the Drishti*net slide shows Admin -> Net after a failover (tutorial 19's capture), its measures in a 2x2 beside it; CHANGELOG
</commit_message>
<xml_diff>
--- a/docs/publications/Drishti-Design-and-Evidence.pptx
+++ b/docs/publications/Drishti-Design-and-Evidence.pptx
@@ -39745,8 +39745,8 @@
         </p:nvSpPr>
         <p:spPr>
           <a:xfrm>
-            <a:off x="777240" y="3474720"/>
-            <a:ext cx="2507742" cy="1737360"/>
+            <a:off x="777240" y="3337560"/>
+            <a:ext cx="2560320" cy="960120"/>
           </a:xfrm>
           <a:prstGeom prst="rect">
             <a:avLst/>
@@ -39765,8 +39765,8 @@
         </p:nvSpPr>
         <p:spPr>
           <a:xfrm>
-            <a:off x="777240" y="3474720"/>
-            <a:ext cx="45720" cy="1737360"/>
+            <a:off x="777240" y="3337560"/>
+            <a:ext cx="45720" cy="960120"/>
           </a:xfrm>
           <a:prstGeom prst="rect">
             <a:avLst/>
@@ -39785,8 +39785,8 @@
         </p:nvSpPr>
         <p:spPr>
           <a:xfrm>
-            <a:off x="978408" y="3584448"/>
-            <a:ext cx="2187702" cy="502920"/>
+            <a:off x="978408" y="3410712"/>
+            <a:ext cx="2240279" cy="384048"/>
           </a:xfrm>
           <a:prstGeom prst="rect">
             <a:avLst/>
@@ -39821,8 +39821,8 @@
         </p:nvSpPr>
         <p:spPr>
           <a:xfrm>
-            <a:off x="978408" y="4078224"/>
-            <a:ext cx="2187702" cy="1060704"/>
+            <a:off x="978408" y="3813048"/>
+            <a:ext cx="2240279" cy="438912"/>
           </a:xfrm>
           <a:prstGeom prst="rect">
             <a:avLst/>
@@ -39857,8 +39857,8 @@
         </p:nvSpPr>
         <p:spPr>
           <a:xfrm>
-            <a:off x="3486150" y="3474720"/>
-            <a:ext cx="2507742" cy="1737360"/>
+            <a:off x="3474720" y="3337560"/>
+            <a:ext cx="2560320" cy="960120"/>
           </a:xfrm>
           <a:prstGeom prst="rect">
             <a:avLst/>
@@ -39877,8 +39877,8 @@
         </p:nvSpPr>
         <p:spPr>
           <a:xfrm>
-            <a:off x="3486150" y="3474720"/>
-            <a:ext cx="45720" cy="1737360"/>
+            <a:off x="3474720" y="3337560"/>
+            <a:ext cx="45720" cy="960120"/>
           </a:xfrm>
           <a:prstGeom prst="rect">
             <a:avLst/>
@@ -39897,8 +39897,8 @@
         </p:nvSpPr>
         <p:spPr>
           <a:xfrm>
-            <a:off x="3687318" y="3584448"/>
-            <a:ext cx="2187702" cy="502920"/>
+            <a:off x="3675888" y="3410712"/>
+            <a:ext cx="2240279" cy="384048"/>
           </a:xfrm>
           <a:prstGeom prst="rect">
             <a:avLst/>
@@ -39933,8 +39933,8 @@
         </p:nvSpPr>
         <p:spPr>
           <a:xfrm>
-            <a:off x="3687318" y="4078224"/>
-            <a:ext cx="2187702" cy="1060704"/>
+            <a:off x="3675888" y="3813048"/>
+            <a:ext cx="2240279" cy="438912"/>
           </a:xfrm>
           <a:prstGeom prst="rect">
             <a:avLst/>
@@ -39969,8 +39969,8 @@
         </p:nvSpPr>
         <p:spPr>
           <a:xfrm>
-            <a:off x="6195060" y="3474720"/>
-            <a:ext cx="2507742" cy="1737360"/>
+            <a:off x="777240" y="4407408"/>
+            <a:ext cx="2560320" cy="960120"/>
           </a:xfrm>
           <a:prstGeom prst="rect">
             <a:avLst/>
@@ -39989,8 +39989,8 @@
         </p:nvSpPr>
         <p:spPr>
           <a:xfrm>
-            <a:off x="6195060" y="3474720"/>
-            <a:ext cx="45720" cy="1737360"/>
+            <a:off x="777240" y="4407408"/>
+            <a:ext cx="45720" cy="960120"/>
           </a:xfrm>
           <a:prstGeom prst="rect">
             <a:avLst/>
@@ -40009,8 +40009,8 @@
         </p:nvSpPr>
         <p:spPr>
           <a:xfrm>
-            <a:off x="6396228" y="3584448"/>
-            <a:ext cx="2187702" cy="502920"/>
+            <a:off x="978408" y="4480560"/>
+            <a:ext cx="2240279" cy="384048"/>
           </a:xfrm>
           <a:prstGeom prst="rect">
             <a:avLst/>
@@ -40045,8 +40045,8 @@
         </p:nvSpPr>
         <p:spPr>
           <a:xfrm>
-            <a:off x="6396228" y="4078224"/>
-            <a:ext cx="2187702" cy="1060704"/>
+            <a:off x="978408" y="4882896"/>
+            <a:ext cx="2240279" cy="438912"/>
           </a:xfrm>
           <a:prstGeom prst="rect">
             <a:avLst/>
@@ -40081,8 +40081,8 @@
         </p:nvSpPr>
         <p:spPr>
           <a:xfrm>
-            <a:off x="8903970" y="3474720"/>
-            <a:ext cx="2507742" cy="1737360"/>
+            <a:off x="3474720" y="4407408"/>
+            <a:ext cx="2560320" cy="960120"/>
           </a:xfrm>
           <a:prstGeom prst="rect">
             <a:avLst/>
@@ -40101,8 +40101,8 @@
         </p:nvSpPr>
         <p:spPr>
           <a:xfrm>
-            <a:off x="8903970" y="3474720"/>
-            <a:ext cx="45720" cy="1737360"/>
+            <a:off x="3474720" y="4407408"/>
+            <a:ext cx="45720" cy="960120"/>
           </a:xfrm>
           <a:prstGeom prst="rect">
             <a:avLst/>
@@ -40121,8 +40121,8 @@
         </p:nvSpPr>
         <p:spPr>
           <a:xfrm>
-            <a:off x="9105138" y="3584448"/>
-            <a:ext cx="2187702" cy="502920"/>
+            <a:off x="3675888" y="4480560"/>
+            <a:ext cx="2240279" cy="384048"/>
           </a:xfrm>
           <a:prstGeom prst="rect">
             <a:avLst/>
@@ -40157,8 +40157,8 @@
         </p:nvSpPr>
         <p:spPr>
           <a:xfrm>
-            <a:off x="9105138" y="4078224"/>
-            <a:ext cx="2187702" cy="1060704"/>
+            <a:off x="3675888" y="4882896"/>
+            <a:ext cx="2240279" cy="438912"/>
           </a:xfrm>
           <a:prstGeom prst="rect">
             <a:avLst/>
@@ -40185,6 +40185,35 @@
           </a:p>
         </p:txBody>
       </p:sp>
+      <p:pic>
+        <p:nvPicPr>
+          <p:cNvPr id="90" name="Admin Net members" descr="Admin → Net on node c after node a stopped: a left, b and c alive; the console's servers: the configured one set aside, a discovered one in use"/>
+          <p:cNvPicPr>
+            <a:picLocks noChangeAspect="1"/>
+          </p:cNvPicPr>
+          <p:nvPr/>
+        </p:nvPicPr>
+        <p:blipFill>
+          <a:blip r:embed="rId90"/>
+          <a:stretch>
+            <a:fillRect/>
+          </a:stretch>
+        </p:blipFill>
+        <p:spPr>
+          <a:xfrm>
+            <a:off x="6549322" y="3337560"/>
+            <a:ext cx="4862389" cy="2029968"/>
+          </a:xfrm>
+          <a:prstGeom prst="rect">
+            <a:avLst/>
+          </a:prstGeom>
+          <a:ln w="9525">
+            <a:solidFill>
+              <a:srgbClr val="D9D9D9"/>
+            </a:solidFill>
+          </a:ln>
+        </p:spPr>
+      </p:pic>
       <p:sp>
         <p:nvSpPr>
           <p:cNvPr id="41" name="Shape 38"/>

</xml_diff>

<commit_message>
Docs, release order as of 2026-10-20 everywhere: BI_DESIGN wave D renamed (statements, field parameters and connectors), send and push, integration and the feeds UI after 3.0.0, the Sajha MCP connector in wave I (2.8.0), the Cassandra connector built and drishti-iceberg being built, acceptance (2) moved with integration; IMPLEMENTATION_PLAN (2.5.0 released, 2.6.0 under way), BI_MODEL_ARCHITECTURE, WRITE_BACK, GENUI, SQL.md; ARCHITECTURE (cassandra plugin, IdentitySync, StateSync, last-admin-kept, real addresses), HOW_IT_FITS (Drishti*net, statements); the deck brought to 2.6.0 (release line, roadmap with after-3.0 row, stores and plugin count 18, tutorials 20, last administrator on any node)
</commit_message>
<xml_diff>
--- a/docs/publications/Drishti-Design-and-Evidence.pptx
+++ b/docs/publications/Drishti-Design-and-Evidence.pptx
@@ -1183,7 +1183,7 @@
           <a:p>
             <a:r>
               <a:rPr lang="en-US" dirty="0"/>
-              <a:t>Source: README.md (name, 'sight', the tagline 'Any data. Any domain. One grammar.'); CHANGELOG.md 2.5.0 (unreleased) and RELEASE_NOTES.md 2.4.0; pom.xml (Java 21 bytecode).
+              <a:t>Source: README.md (name, 'sight', the tagline 'Any data. Any domain. One grammar.'); CHANGELOG.md 2.5.0 and Unreleased (2.6.0); RELEASE_NOTES.md 2.5.0; pom.xml (Java 21 bytecode).
 Talk track: Drishti is Sanskrit for sight. The promise is in the tagline: any record from any system, in any domain, shown through one grammar instead of a screen written per product. The deck runs idea, product, security, evidence and roadmap; every number in it is measured or counted from the repository.</a:t>
             </a:r>
             <a:endParaRPr lang="en-US" dirty="0"/>
@@ -1272,7 +1272,7 @@
           <a:p>
             <a:r>
               <a:rPr lang="en-US" dirty="0"/>
-              <a:t>Source: README.md 'How it is built'; pom.xml modules (drishti-net, drishti-deltalake); ARCHITECTURE.md §2, §13 and §13a; NET.md.
+              <a:t>Source: README.md 'How it is built'; pom.xml modules (drishti-net, drishti-deltalake); ARCHITECTURE.md §2, §13 and §13a; NET.md; CASSANDRA_CONNECTOR.md (the Cassandra plugin, 2.6.0).
 Talk track: Modules depend one way only, and an architecture test enforces it. The plugin interface is Spring-free so connectors stay small. With Drishti*net on, several such servers act as one: each keeps its own sources, and any of them answers.</a:t>
             </a:r>
             <a:endParaRPr lang="en-US" dirty="0"/>
@@ -1806,7 +1806,7 @@
           <a:p>
             <a:r>
               <a:rPr lang="en-US" dirty="0"/>
-              <a:t>Source: README.md; config/packs (7 packs, 197 Sutra files); PANELS.md (22 kinds); pom.xml plugins (17); CHANGELOG 2.3.0 to 2.5.0.
+              <a:t>Source: README.md; config/packs (7 packs, 197 Sutra files); PANELS.md (22 kinds); plugins/ (18, with Cassandra in 2.6.0); CHANGELOG 2.3.0 to 2.5.0.
 Talk track: The numbers are counted from the repository on 19 October 2026.</a:t>
             </a:r>
             <a:endParaRPr lang="en-US" dirty="0"/>
@@ -2162,7 +2162,7 @@
           <a:p>
             <a:r>
               <a:rPr lang="en-US" dirty="0"/>
-              <a:t>Source: README.md; ARCHITECTURE.md §1; CHANGELOG.md 2.4.0 and 2.5.0; docs/admin/PERFORMANCE.md (35.7 million trades, 50 users, 179 requests/s); BI_DESIGN.md §12.2 (release order); counts from git ls-files on 19 October 2026.
+              <a:t>Source: README.md; ARCHITECTURE.md §1; CHANGELOG.md 2.4.0 and 2.5.0; docs/admin/PERFORMANCE.md (35.7 million trades, 50 users, 179 requests/s); BI_DESIGN.md §12.2 (release order); counts from git ls-files on 20 October 2026 (plugins/: 18 source plugins with Cassandra).
 Talk track: If you remember one slide, make it this one. Five questions and five short answers; the rest of the deck earns each answer.</a:t>
             </a:r>
             <a:endParaRPr lang="en-US" dirty="0"/>
@@ -3052,7 +3052,7 @@
           <a:p>
             <a:r>
               <a:rPr lang="en-US" dirty="0"/>
-              <a:t>Source: USER_MANAGEMENT.md §5–6; OPERATIONS.md §8.4 (CSRF, cookies); ADR-014.
+              <a:t>Source: USER_MANAGEMENT.md §5–6; OPERATIONS.md §8.4 (CSRF, cookies); ADR-014; NET.md section 7 and NetLastAdminTest (the last-administrator rule repaired across nodes, audited last-admin-kept).
 Talk track: The console holds no credential of its own; the server decides, and re-checks every ten seconds.</a:t>
             </a:r>
             <a:endParaRPr lang="en-US" dirty="0"/>
@@ -4031,7 +4031,7 @@
           <a:p>
             <a:r>
               <a:rPr lang="en-US" dirty="0"/>
-              <a:t>Source: git ls-files | wc -l by language, 19 October 2026 (vendored and built assets left out); docs/ (155 Markdown documents outside qa/).
+              <a:t>Source: git ls-files | wc -l by language, 20 October 2026 (vendored and built assets left out); docs/ (162 Markdown documents outside qa/).
 Talk track: Packs are mostly sample data and Sutras. The Java is split into small modules that depend one way.</a:t>
             </a:r>
             <a:endParaRPr lang="en-US" dirty="0"/>
@@ -4209,7 +4209,7 @@
           <a:p>
             <a:r>
               <a:rPr lang="en-US" dirty="0"/>
-              <a:t>Source: docs/architecture/BI_DESIGN.md §12.2 (the release order agreed on 2026-10-19); IMPLEMENTATION_PLAN.md 'Roadmap'.
+              <a:t>Source: docs/architecture/BI_DESIGN.md §12.2 (the release order agreed on 2026-10-19 and changed on 2026-10-20); IMPLEMENTATION_PLAN.md 'Roadmap'.
 Talk track: What is left, in order.</a:t>
             </a:r>
             <a:endParaRPr lang="en-US" dirty="0"/>
@@ -4298,7 +4298,7 @@
           <a:p>
             <a:r>
               <a:rPr lang="en-US" dirty="0"/>
-              <a:t>Source: docs/architecture/BI_DESIGN.md §12.2 (waves N, D, I, E; after E, 3.0); IMPLEMENTATION_PLAN.md 'Roadmap'; GENUI.md; AI_MANAGEMENT.md; QUANT_SERVICE.md.
+              <a:t>Source: docs/architecture/BI_DESIGN.md §12.2 (waves D, W, I, E; after E, 3.0; send and push and integration after 3.0.0, product owner 2026-10-20); WRITE_BACK.md; IMPLEMENTATION_PLAN.md 'Roadmap'; GENUI.md; AI_MANAGEMENT.md; QUANT_SERVICE.md.
 Talk track: 2.5.0 is built and in its release testing. Then sharing and integration, then AI, then the product owner's real-life QA, whose findings lead 2.8.0, then 3.0.</a:t>
             </a:r>
             <a:endParaRPr lang="en-US" dirty="0"/>
@@ -4833,7 +4833,7 @@
             <a:r>
               <a:rPr lang="en-US" dirty="0"/>
               <a:t>Source: CHANGELOG.md 2.5.0 (N1 to N7: three servers in one JVM converge 52 ms after the third starts; five nodes, fake clock: dead everywhere within 40 s; a pack in the others' tables 1.0 s later; 13,542 signed calls through the rotation); docs/admin/NET.md; DRISHTI_NET.md §19.
-Talk track: Off by default. Switched on, servers gossip over HTTP with calls signed by a rotating cluster key. A request goes whole to a node that renders the kind, or the document is fetched from the node that holds it; a search is scattered and merged; the console fails over with no new sign-in.</a:t>
+Talk track: Off by default. Switched on, servers gossip over HTTP with calls signed by a rotating cluster key. A request goes whole to a node that renders the kind, or the document is fetched from the node that holds it; a search is scattered and merged; the console fails over with no new sign-in. Since 2.6.0 a member advertises only a real address (localhost, 127.x, ::1, 0.0.0.0 and :: are refused in node.yaml, peers and gossip), and a peer's change that would leave no enabled administrator is repaired where it is applied, audited last-admin-kept (NET.md sections 2 and 7; NetLastAdminTest).</a:t>
             </a:r>
             <a:endParaRPr lang="en-US" dirty="0"/>
           </a:p>
@@ -6160,6 +6160,10 @@
           </a:solidFill>
           <a:ln/>
         </p:spPr>
+        <p:txBody>
+          <a:bodyPr/>
+          <a:p/>
+        </p:txBody>
       </p:sp>
       <p:sp>
         <p:nvSpPr>
@@ -6180,6 +6184,10 @@
           </a:solidFill>
           <a:ln/>
         </p:spPr>
+        <p:txBody>
+          <a:bodyPr/>
+          <a:p/>
+        </p:txBody>
       </p:sp>
       <p:sp>
         <p:nvSpPr>
@@ -6200,6 +6208,10 @@
           </a:solidFill>
           <a:ln/>
         </p:spPr>
+        <p:txBody>
+          <a:bodyPr/>
+          <a:p/>
+        </p:txBody>
       </p:sp>
       <p:sp>
         <p:nvSpPr>
@@ -6225,6 +6237,10 @@
             <a:prstDash val="solid"/>
           </a:ln>
         </p:spPr>
+        <p:txBody>
+          <a:bodyPr/>
+          <a:p/>
+        </p:txBody>
       </p:sp>
       <p:sp>
         <p:nvSpPr>
@@ -6250,6 +6266,10 @@
             <a:prstDash val="solid"/>
           </a:ln>
         </p:spPr>
+        <p:txBody>
+          <a:bodyPr/>
+          <a:p/>
+        </p:txBody>
       </p:sp>
       <p:sp>
         <p:nvSpPr>
@@ -6275,6 +6295,10 @@
             <a:prstDash val="solid"/>
           </a:ln>
         </p:spPr>
+        <p:txBody>
+          <a:bodyPr/>
+          <a:p/>
+        </p:txBody>
       </p:sp>
       <p:sp>
         <p:nvSpPr>
@@ -6381,6 +6405,10 @@
           </a:solidFill>
           <a:ln/>
         </p:spPr>
+        <p:txBody>
+          <a:bodyPr/>
+          <a:p/>
+        </p:txBody>
       </p:sp>
       <p:sp>
         <p:nvSpPr>
@@ -6476,7 +6504,7 @@
                   <a:srgbClr val="61666E"/>
                 </a:solidFill>
               </a:rPr>
-              <a:t>Release 2.5.0 · Java 21 or later · console on any device</a:t>
+              <a:t>Release 2.5.0, 2.6.0 under way · Java 21 or later · console on any device</a:t>
             </a:r>
             <a:endParaRPr lang="en-US" sz="2000" dirty="0"/>
           </a:p>
@@ -6823,6 +6851,10 @@
           </a:solidFill>
           <a:ln/>
         </p:spPr>
+        <p:txBody>
+          <a:bodyPr/>
+          <a:p/>
+        </p:txBody>
       </p:sp>
       <p:sp>
         <p:nvSpPr>
@@ -6855,6 +6887,10 @@
             </a:outerShdw>
           </a:effectLst>
         </p:spPr>
+        <p:txBody>
+          <a:bodyPr/>
+          <a:p/>
+        </p:txBody>
       </p:sp>
       <p:sp>
         <p:nvSpPr>
@@ -6922,7 +6958,7 @@
                   <a:srgbClr val="4A5058"/>
                 </a:solidFill>
               </a:rPr>
-              <a:t>Delta Lake, JDBC, Aerospike, MongoDB, Redis, Iceberg, DuckDB</a:t>
+              <a:t>Delta, JDBC, Aerospike, Cassandra, MongoDB, Redis, Iceberg, DuckDB</a:t>
             </a:r>
             <a:endParaRPr lang="en-US" sz="1100" dirty="0"/>
           </a:p>
@@ -6959,6 +6995,10 @@
             </a:outerShdw>
           </a:effectLst>
         </p:spPr>
+        <p:txBody>
+          <a:bodyPr/>
+          <a:p/>
+        </p:txBody>
       </p:sp>
       <p:sp>
         <p:nvSpPr>
@@ -7063,6 +7103,10 @@
             </a:outerShdw>
           </a:effectLst>
         </p:spPr>
+        <p:txBody>
+          <a:bodyPr/>
+          <a:p/>
+        </p:txBody>
       </p:sp>
       <p:sp>
         <p:nvSpPr>
@@ -7167,6 +7211,10 @@
             </a:outerShdw>
           </a:effectLst>
         </p:spPr>
+        <p:txBody>
+          <a:bodyPr/>
+          <a:p/>
+        </p:txBody>
       </p:sp>
       <p:sp>
         <p:nvSpPr>
@@ -7271,6 +7319,10 @@
             </a:outerShdw>
           </a:effectLst>
         </p:spPr>
+        <p:txBody>
+          <a:bodyPr/>
+          <a:p/>
+        </p:txBody>
       </p:sp>
       <p:sp>
         <p:nvSpPr>
@@ -7374,7 +7426,7 @@
                   <a:srgbClr val="4A5058"/>
                 </a:solidFill>
               </a:rPr>
-              <a:t>Virtual threads fetch in parallel; the engine matches a Sutra, merges inference, links ids and binds values; BI models answer on DuckDB — 17 source plugins</a:t>
+              <a:t>Virtual threads fetch in parallel; the engine matches a Sutra, merges inference, links ids and binds values; BI models answer on DuckDB — 18 source plugins</a:t>
             </a:r>
             <a:endParaRPr lang="en-US" sz="1200" dirty="0"/>
           </a:p>
@@ -12773,7 +12825,7 @@
                   <a:srgbClr val="A51C30"/>
                 </a:solidFill>
               </a:rPr>
-              <a:t>RELEASE 2.5 · JAVA 21 OR LATER</a:t>
+              <a:t>RELEASE 2.5, 2.6 UNDER WAY · JAVA 21 OR LATER</a:t>
             </a:r>
             <a:endParaRPr lang="en-US" sz="1050" dirty="0"/>
           </a:p>
@@ -12836,6 +12888,10 @@
           </a:solidFill>
           <a:ln/>
         </p:spPr>
+        <p:txBody>
+          <a:bodyPr/>
+          <a:p/>
+        </p:txBody>
       </p:sp>
       <p:sp>
         <p:nvSpPr>
@@ -12856,6 +12912,10 @@
           </a:solidFill>
           <a:ln/>
         </p:spPr>
+        <p:txBody>
+          <a:bodyPr/>
+          <a:p/>
+        </p:txBody>
       </p:sp>
       <p:sp>
         <p:nvSpPr>
@@ -12876,6 +12936,10 @@
           </a:solidFill>
           <a:ln/>
         </p:spPr>
+        <p:txBody>
+          <a:bodyPr/>
+          <a:p/>
+        </p:txBody>
       </p:sp>
       <p:sp>
         <p:nvSpPr>
@@ -12968,6 +13032,10 @@
           </a:solidFill>
           <a:ln/>
         </p:spPr>
+        <p:txBody>
+          <a:bodyPr/>
+          <a:p/>
+        </p:txBody>
       </p:sp>
       <p:sp>
         <p:nvSpPr>
@@ -12988,6 +13056,10 @@
           </a:solidFill>
           <a:ln/>
         </p:spPr>
+        <p:txBody>
+          <a:bodyPr/>
+          <a:p/>
+        </p:txBody>
       </p:sp>
       <p:sp>
         <p:nvSpPr>
@@ -13080,6 +13152,10 @@
           </a:solidFill>
           <a:ln/>
         </p:spPr>
+        <p:txBody>
+          <a:bodyPr/>
+          <a:p/>
+        </p:txBody>
       </p:sp>
       <p:sp>
         <p:nvSpPr>
@@ -13100,6 +13176,10 @@
           </a:solidFill>
           <a:ln/>
         </p:spPr>
+        <p:txBody>
+          <a:bodyPr/>
+          <a:p/>
+        </p:txBody>
       </p:sp>
       <p:sp>
         <p:nvSpPr>
@@ -13192,6 +13272,10 @@
           </a:solidFill>
           <a:ln/>
         </p:spPr>
+        <p:txBody>
+          <a:bodyPr/>
+          <a:p/>
+        </p:txBody>
       </p:sp>
       <p:sp>
         <p:nvSpPr>
@@ -13212,6 +13296,10 @@
           </a:solidFill>
           <a:ln/>
         </p:spPr>
+        <p:txBody>
+          <a:bodyPr/>
+          <a:p/>
+        </p:txBody>
       </p:sp>
       <p:sp>
         <p:nvSpPr>
@@ -13243,7 +13331,7 @@
                   <a:srgbClr val="8A1626"/>
                 </a:solidFill>
               </a:rPr>
-              <a:t>17</a:t>
+              <a:t>18</a:t>
             </a:r>
             <a:endParaRPr lang="en-US" sz="2600" dirty="0"/>
           </a:p>
@@ -13363,7 +13451,7 @@
                   <a:srgbClr val="4A5058"/>
                 </a:solidFill>
               </a:rPr>
-              <a:t>The Build workbench for screens; BI Studio for reports, models, boards and themes; Python data prep step by step.</a:t>
+              <a:t>The Build workbench for screens; BI Studio for reports, statements, models, boards and themes; Python data prep step by step.</a:t>
             </a:r>
             <a:endParaRPr lang="en-US" sz="1500" dirty="0"/>
           </a:p>
@@ -15259,7 +15347,7 @@
                   <a:srgbClr val="1A1A1A"/>
                 </a:solidFill>
               </a:rPr>
-              <a:t>Release 2.5: 7 packs, 197 Sutras, 22 panel kinds, 17 source plugins, BI Studio, Python data prep, several servers as one (Drishti*net); 35.7 million trades served to 50 users at 179 requests/s.</a:t>
+              <a:t>Release 2.5 and 2.6 so far: 7 packs, 197 Sutras, 22 panel kinds, 18 source plugins, BI Studio with statements, Python data prep, several servers as one (Drishti*net); 35.7 million trades served to 50 users at 179 requests/s.</a:t>
             </a:r>
             <a:endParaRPr lang="en-US" sz="1300" dirty="0"/>
           </a:p>
@@ -15391,7 +15479,7 @@
                   <a:srgbClr val="1A1A1A"/>
                 </a:solidFill>
               </a:rPr>
-              <a:t>2.6.0 sharing and integration; 2.7.0 AI (GenUI, AI management); a real-life QA; 2.8.0 production readiness; then 3.0.</a:t>
+              <a:t>2.6.0 statements, field parameters, Cassandra, Iceberg without Hadoop; 2.7.0 write-back; 2.8.0 AI and GenUI; a real-life QA; 2.9.0 production readiness; then 3.0.</a:t>
             </a:r>
             <a:endParaRPr lang="en-US" sz="1300" dirty="0"/>
           </a:p>
@@ -25058,6 +25146,10 @@
           </a:solidFill>
           <a:ln/>
         </p:spPr>
+        <p:txBody>
+          <a:bodyPr/>
+          <a:p/>
+        </p:txBody>
       </p:sp>
       <p:sp>
         <p:nvSpPr>
@@ -25078,6 +25170,10 @@
           </a:solidFill>
           <a:ln/>
         </p:spPr>
+        <p:txBody>
+          <a:bodyPr/>
+          <a:p/>
+        </p:txBody>
       </p:sp>
       <p:sp>
         <p:nvSpPr>
@@ -25098,6 +25194,10 @@
           </a:solidFill>
           <a:ln/>
         </p:spPr>
+        <p:txBody>
+          <a:bodyPr/>
+          <a:p/>
+        </p:txBody>
       </p:sp>
       <p:sp>
         <p:nvSpPr>
@@ -25435,7 +25535,7 @@
                   <a:srgbClr val="4A5058"/>
                 </a:solidFill>
               </a:rPr>
-              <a:t>You cannot remove the last administrator.</a:t>
+              <a:t>You cannot remove the last administrator, on any node of a cluster.</a:t>
             </a:r>
             <a:endParaRPr lang="en-US" sz="1500" dirty="0"/>
           </a:p>
@@ -38997,6 +39097,10 @@
           </a:solidFill>
           <a:ln/>
         </p:spPr>
+        <p:txBody>
+          <a:bodyPr/>
+          <a:p/>
+        </p:txBody>
       </p:sp>
       <p:graphicFrame>
         <p:nvGraphicFramePr>
@@ -39044,7 +39148,7 @@
                   <a:srgbClr val="A51C30"/>
                 </a:solidFill>
               </a:rPr>
-              <a:t>▪  155 guides and references</a:t>
+              <a:t>▪  162 guides and references</a:t>
             </a:r>
             <a:endParaRPr lang="en-US" sz="1500" dirty="0"/>
           </a:p>
@@ -39061,7 +39165,7 @@
                   <a:srgbClr val="4A5058"/>
                 </a:solidFill>
               </a:rPr>
-              <a:t>User, admin, CLI, BI, packs, connectors, architecture, 19 tutorials and 21 ADRs.</a:t>
+              <a:t>User, admin, CLI, BI, packs, connectors, architecture, 20 tutorials and 21 ADRs.</a:t>
             </a:r>
             <a:endParaRPr lang="en-US" sz="1500" dirty="0"/>
           </a:p>
@@ -39123,7 +39227,7 @@
                   <a:srgbClr val="4A5058"/>
                 </a:solidFill>
               </a:rPr>
-              <a:t>Plus 17 source plugins, a server, integration tests and benchmarks.</a:t>
+              <a:t>Plus 18 source plugins, a server, integration tests and benchmarks.</a:t>
             </a:r>
             <a:endParaRPr lang="en-US" sz="1500" dirty="0"/>
           </a:p>
@@ -39396,7 +39500,7 @@
                   <a:srgbClr val="F6E6E9"/>
                 </a:solidFill>
               </a:rPr>
-              <a:t>Sharing and integration, then AI, then a real-life QA and production readiness, then 3.0.</a:t>
+              <a:t>Statements and connectors, then write-back, then AI, then a real-life QA and production readiness, then 3.0.</a:t>
             </a:r>
             <a:endParaRPr lang="en-US" sz="1900" dirty="0"/>
           </a:p>
@@ -39795,7 +39899,7 @@
                             <a:srgbClr val="8A1626"/>
                           </a:solidFill>
                         </a:rPr>
-                        <a:t>2.5.0 Drishti*net</a:t>
+                        <a:t>2.6.0 Statements</a:t>
                       </a:r>
                       <a:endParaRPr lang="en-US" sz="1350" dirty="0"/>
                     </a:p>
@@ -39856,7 +39960,7 @@
                             <a:srgbClr val="1A1A1A"/>
                           </a:solidFill>
                         </a:rPr>
-                        <a:t>Several servers as one: gossip, digests, routing, scatter-gather, failover; built, in release testing</a:t>
+                        <a:t>The known-bug pass; paginated reports and statements; field parameters in wells; the Cassandra connector; Iceberg without Hadoop</a:t>
                       </a:r>
                       <a:endParaRPr lang="en-US" sz="1350" dirty="0"/>
                     </a:p>
@@ -39900,191 +40004,6 @@
                     </a:lnB>
                     <a:solidFill>
                       <a:srgbClr val="F7F5F2"/>
-                    </a:solidFill>
-                  </a:tcPr>
-                </a:tc>
-                <a:tc>
-                  <a:txBody>
-                    <a:bodyPr/>
-                    <a:lstStyle/>
-                    <a:p>
-                      <a:pPr indent="0" marL="0">
-                        <a:buNone/>
-                      </a:pPr>
-                      <a:r>
-                        <a:rPr lang="en-US" sz="1350" dirty="0">
-                          <a:solidFill>
-                            <a:srgbClr val="1A1A1A"/>
-                          </a:solidFill>
-                        </a:rPr>
-                        <a:t>The browser rehearsal and the drill pass</a:t>
-                      </a:r>
-                      <a:endParaRPr lang="en-US" sz="1350" dirty="0"/>
-                    </a:p>
-                  </a:txBody>
-                  <a:tcPr marL="88900" marR="88900" marT="50800" marB="50800" anchor="ctr">
-                    <a:lnL w="6350" cap="flat" cmpd="sng" algn="ctr">
-                      <a:solidFill>
-                        <a:srgbClr val="E3DED7"/>
-                      </a:solidFill>
-                      <a:prstDash val="solid"/>
-                      <a:round/>
-                      <a:headEnd type="none" w="med" len="med"/>
-                      <a:tailEnd type="none" w="med" len="med"/>
-                    </a:lnL>
-                    <a:lnR w="6350" cap="flat" cmpd="sng" algn="ctr">
-                      <a:solidFill>
-                        <a:srgbClr val="E3DED7"/>
-                      </a:solidFill>
-                      <a:prstDash val="solid"/>
-                      <a:round/>
-                      <a:headEnd type="none" w="med" len="med"/>
-                      <a:tailEnd type="none" w="med" len="med"/>
-                    </a:lnR>
-                    <a:lnT w="6350" cap="flat" cmpd="sng" algn="ctr">
-                      <a:solidFill>
-                        <a:srgbClr val="E3DED7"/>
-                      </a:solidFill>
-                      <a:prstDash val="solid"/>
-                      <a:round/>
-                      <a:headEnd type="none" w="med" len="med"/>
-                      <a:tailEnd type="none" w="med" len="med"/>
-                    </a:lnT>
-                    <a:lnB w="6350" cap="flat" cmpd="sng" algn="ctr">
-                      <a:solidFill>
-                        <a:srgbClr val="E3DED7"/>
-                      </a:solidFill>
-                      <a:prstDash val="solid"/>
-                      <a:round/>
-                      <a:headEnd type="none" w="med" len="med"/>
-                      <a:tailEnd type="none" w="med" len="med"/>
-                    </a:lnB>
-                    <a:solidFill>
-                      <a:srgbClr val="F7F5F2"/>
-                    </a:solidFill>
-                  </a:tcPr>
-                </a:tc>
-              </a:tr>
-              <a:tr h="585216">
-                <a:tc>
-                  <a:txBody>
-                    <a:bodyPr/>
-                    <a:lstStyle/>
-                    <a:p>
-                      <a:pPr indent="0" marL="0">
-                        <a:buNone/>
-                      </a:pPr>
-                      <a:r>
-                        <a:rPr lang="en-US" sz="1350" b="1" dirty="0">
-                          <a:solidFill>
-                            <a:srgbClr val="8A1626"/>
-                          </a:solidFill>
-                        </a:rPr>
-                        <a:t>2.6.0 Sharing</a:t>
-                      </a:r>
-                      <a:endParaRPr lang="en-US" sz="1350" dirty="0"/>
-                    </a:p>
-                  </a:txBody>
-                  <a:tcPr marL="88900" marR="88900" marT="50800" marB="50800" anchor="ctr">
-                    <a:lnL w="6350" cap="flat" cmpd="sng" algn="ctr">
-                      <a:solidFill>
-                        <a:srgbClr val="E3DED7"/>
-                      </a:solidFill>
-                      <a:prstDash val="solid"/>
-                      <a:round/>
-                      <a:headEnd type="none" w="med" len="med"/>
-                      <a:tailEnd type="none" w="med" len="med"/>
-                    </a:lnL>
-                    <a:lnR w="6350" cap="flat" cmpd="sng" algn="ctr">
-                      <a:solidFill>
-                        <a:srgbClr val="E3DED7"/>
-                      </a:solidFill>
-                      <a:prstDash val="solid"/>
-                      <a:round/>
-                      <a:headEnd type="none" w="med" len="med"/>
-                      <a:tailEnd type="none" w="med" len="med"/>
-                    </a:lnR>
-                    <a:lnT w="6350" cap="flat" cmpd="sng" algn="ctr">
-                      <a:solidFill>
-                        <a:srgbClr val="E3DED7"/>
-                      </a:solidFill>
-                      <a:prstDash val="solid"/>
-                      <a:round/>
-                      <a:headEnd type="none" w="med" len="med"/>
-                      <a:tailEnd type="none" w="med" len="med"/>
-                    </a:lnT>
-                    <a:lnB w="6350" cap="flat" cmpd="sng" algn="ctr">
-                      <a:solidFill>
-                        <a:srgbClr val="E3DED7"/>
-                      </a:solidFill>
-                      <a:prstDash val="solid"/>
-                      <a:round/>
-                      <a:headEnd type="none" w="med" len="med"/>
-                      <a:tailEnd type="none" w="med" len="med"/>
-                    </a:lnB>
-                    <a:solidFill>
-                      <a:srgbClr val="FFFFFF"/>
-                    </a:solidFill>
-                  </a:tcPr>
-                </a:tc>
-                <a:tc>
-                  <a:txBody>
-                    <a:bodyPr/>
-                    <a:lstStyle/>
-                    <a:p>
-                      <a:pPr indent="0" marL="0">
-                        <a:buNone/>
-                      </a:pPr>
-                      <a:r>
-                        <a:rPr lang="en-US" sz="1350" dirty="0">
-                          <a:solidFill>
-                            <a:srgbClr val="1A1A1A"/>
-                          </a:solidFill>
-                        </a:rPr>
-                        <a:t>Paginated reports, send and push, SQL and Excel feeds, embed tokens, the Sajha MCP connector, field parameters</a:t>
-                      </a:r>
-                      <a:endParaRPr lang="en-US" sz="1350" dirty="0"/>
-                    </a:p>
-                  </a:txBody>
-                  <a:tcPr marL="88900" marR="88900" marT="50800" marB="50800" anchor="ctr">
-                    <a:lnL w="6350" cap="flat" cmpd="sng" algn="ctr">
-                      <a:solidFill>
-                        <a:srgbClr val="E3DED7"/>
-                      </a:solidFill>
-                      <a:prstDash val="solid"/>
-                      <a:round/>
-                      <a:headEnd type="none" w="med" len="med"/>
-                      <a:tailEnd type="none" w="med" len="med"/>
-                    </a:lnL>
-                    <a:lnR w="6350" cap="flat" cmpd="sng" algn="ctr">
-                      <a:solidFill>
-                        <a:srgbClr val="E3DED7"/>
-                      </a:solidFill>
-                      <a:prstDash val="solid"/>
-                      <a:round/>
-                      <a:headEnd type="none" w="med" len="med"/>
-                      <a:tailEnd type="none" w="med" len="med"/>
-                    </a:lnR>
-                    <a:lnT w="6350" cap="flat" cmpd="sng" algn="ctr">
-                      <a:solidFill>
-                        <a:srgbClr val="E3DED7"/>
-                      </a:solidFill>
-                      <a:prstDash val="solid"/>
-                      <a:round/>
-                      <a:headEnd type="none" w="med" len="med"/>
-                      <a:tailEnd type="none" w="med" len="med"/>
-                    </a:lnT>
-                    <a:lnB w="6350" cap="flat" cmpd="sng" algn="ctr">
-                      <a:solidFill>
-                        <a:srgbClr val="E3DED7"/>
-                      </a:solidFill>
-                      <a:prstDash val="solid"/>
-                      <a:round/>
-                      <a:headEnd type="none" w="med" len="med"/>
-                      <a:tailEnd type="none" w="med" len="med"/>
-                    </a:lnB>
-                    <a:solidFill>
-                      <a:srgbClr val="FFFFFF"/>
                     </a:solidFill>
                   </a:tcPr>
                 </a:tc>
@@ -40145,6 +40064,191 @@
                       <a:tailEnd type="none" w="med" len="med"/>
                     </a:lnB>
                     <a:solidFill>
+                      <a:srgbClr val="F7F5F2"/>
+                    </a:solidFill>
+                  </a:tcPr>
+                </a:tc>
+              </a:tr>
+              <a:tr h="585216">
+                <a:tc>
+                  <a:txBody>
+                    <a:bodyPr/>
+                    <a:lstStyle/>
+                    <a:p>
+                      <a:pPr indent="0" marL="0">
+                        <a:buNone/>
+                      </a:pPr>
+                      <a:r>
+                        <a:rPr lang="en-US" sz="1350" b="1" dirty="0">
+                          <a:solidFill>
+                            <a:srgbClr val="8A1626"/>
+                          </a:solidFill>
+                        </a:rPr>
+                        <a:t>2.7.0 Write-back</a:t>
+                      </a:r>
+                      <a:endParaRPr lang="en-US" sz="1350" dirty="0"/>
+                    </a:p>
+                  </a:txBody>
+                  <a:tcPr marL="88900" marR="88900" marT="50800" marB="50800" anchor="ctr">
+                    <a:lnL w="6350" cap="flat" cmpd="sng" algn="ctr">
+                      <a:solidFill>
+                        <a:srgbClr val="E3DED7"/>
+                      </a:solidFill>
+                      <a:prstDash val="solid"/>
+                      <a:round/>
+                      <a:headEnd type="none" w="med" len="med"/>
+                      <a:tailEnd type="none" w="med" len="med"/>
+                    </a:lnL>
+                    <a:lnR w="6350" cap="flat" cmpd="sng" algn="ctr">
+                      <a:solidFill>
+                        <a:srgbClr val="E3DED7"/>
+                      </a:solidFill>
+                      <a:prstDash val="solid"/>
+                      <a:round/>
+                      <a:headEnd type="none" w="med" len="med"/>
+                      <a:tailEnd type="none" w="med" len="med"/>
+                    </a:lnR>
+                    <a:lnT w="6350" cap="flat" cmpd="sng" algn="ctr">
+                      <a:solidFill>
+                        <a:srgbClr val="E3DED7"/>
+                      </a:solidFill>
+                      <a:prstDash val="solid"/>
+                      <a:round/>
+                      <a:headEnd type="none" w="med" len="med"/>
+                      <a:tailEnd type="none" w="med" len="med"/>
+                    </a:lnT>
+                    <a:lnB w="6350" cap="flat" cmpd="sng" algn="ctr">
+                      <a:solidFill>
+                        <a:srgbClr val="E3DED7"/>
+                      </a:solidFill>
+                      <a:prstDash val="solid"/>
+                      <a:round/>
+                      <a:headEnd type="none" w="med" len="med"/>
+                      <a:tailEnd type="none" w="med" len="med"/>
+                    </a:lnB>
+                    <a:solidFill>
+                      <a:srgbClr val="FFFFFF"/>
+                    </a:solidFill>
+                  </a:tcPr>
+                </a:tc>
+                <a:tc>
+                  <a:txBody>
+                    <a:bodyPr/>
+                    <a:lstStyle/>
+                    <a:p>
+                      <a:pPr indent="0" marL="0">
+                        <a:buNone/>
+                      </a:pPr>
+                      <a:r>
+                        <a:rPr lang="en-US" sz="1350" dirty="0">
+                          <a:solidFill>
+                            <a:srgbClr val="1A1A1A"/>
+                          </a:solidFill>
+                        </a:rPr>
+                        <a:t>Edit and save fields on a Sutra page: ordered lanes, version checks, four eyes, overlays into the lake</a:t>
+                      </a:r>
+                      <a:endParaRPr lang="en-US" sz="1350" dirty="0"/>
+                    </a:p>
+                  </a:txBody>
+                  <a:tcPr marL="88900" marR="88900" marT="50800" marB="50800" anchor="ctr">
+                    <a:lnL w="6350" cap="flat" cmpd="sng" algn="ctr">
+                      <a:solidFill>
+                        <a:srgbClr val="E3DED7"/>
+                      </a:solidFill>
+                      <a:prstDash val="solid"/>
+                      <a:round/>
+                      <a:headEnd type="none" w="med" len="med"/>
+                      <a:tailEnd type="none" w="med" len="med"/>
+                    </a:lnL>
+                    <a:lnR w="6350" cap="flat" cmpd="sng" algn="ctr">
+                      <a:solidFill>
+                        <a:srgbClr val="E3DED7"/>
+                      </a:solidFill>
+                      <a:prstDash val="solid"/>
+                      <a:round/>
+                      <a:headEnd type="none" w="med" len="med"/>
+                      <a:tailEnd type="none" w="med" len="med"/>
+                    </a:lnR>
+                    <a:lnT w="6350" cap="flat" cmpd="sng" algn="ctr">
+                      <a:solidFill>
+                        <a:srgbClr val="E3DED7"/>
+                      </a:solidFill>
+                      <a:prstDash val="solid"/>
+                      <a:round/>
+                      <a:headEnd type="none" w="med" len="med"/>
+                      <a:tailEnd type="none" w="med" len="med"/>
+                    </a:lnT>
+                    <a:lnB w="6350" cap="flat" cmpd="sng" algn="ctr">
+                      <a:solidFill>
+                        <a:srgbClr val="E3DED7"/>
+                      </a:solidFill>
+                      <a:prstDash val="solid"/>
+                      <a:round/>
+                      <a:headEnd type="none" w="med" len="med"/>
+                      <a:tailEnd type="none" w="med" len="med"/>
+                    </a:lnB>
+                    <a:solidFill>
+                      <a:srgbClr val="FFFFFF"/>
+                    </a:solidFill>
+                  </a:tcPr>
+                </a:tc>
+                <a:tc>
+                  <a:txBody>
+                    <a:bodyPr/>
+                    <a:lstStyle/>
+                    <a:p>
+                      <a:pPr indent="0" marL="0">
+                        <a:buNone/>
+                      </a:pPr>
+                      <a:r>
+                        <a:rPr lang="en-US" sz="1350" dirty="0">
+                          <a:solidFill>
+                            <a:srgbClr val="1A1A1A"/>
+                          </a:solidFill>
+                        </a:rPr>
+                        <a:t>Two users editing one field never overwrite each other silently</a:t>
+                      </a:r>
+                      <a:endParaRPr lang="en-US" sz="1350" dirty="0"/>
+                    </a:p>
+                  </a:txBody>
+                  <a:tcPr marL="88900" marR="88900" marT="50800" marB="50800" anchor="ctr">
+                    <a:lnL w="6350" cap="flat" cmpd="sng" algn="ctr">
+                      <a:solidFill>
+                        <a:srgbClr val="E3DED7"/>
+                      </a:solidFill>
+                      <a:prstDash val="solid"/>
+                      <a:round/>
+                      <a:headEnd type="none" w="med" len="med"/>
+                      <a:tailEnd type="none" w="med" len="med"/>
+                    </a:lnL>
+                    <a:lnR w="6350" cap="flat" cmpd="sng" algn="ctr">
+                      <a:solidFill>
+                        <a:srgbClr val="E3DED7"/>
+                      </a:solidFill>
+                      <a:prstDash val="solid"/>
+                      <a:round/>
+                      <a:headEnd type="none" w="med" len="med"/>
+                      <a:tailEnd type="none" w="med" len="med"/>
+                    </a:lnR>
+                    <a:lnT w="6350" cap="flat" cmpd="sng" algn="ctr">
+                      <a:solidFill>
+                        <a:srgbClr val="E3DED7"/>
+                      </a:solidFill>
+                      <a:prstDash val="solid"/>
+                      <a:round/>
+                      <a:headEnd type="none" w="med" len="med"/>
+                      <a:tailEnd type="none" w="med" len="med"/>
+                    </a:lnT>
+                    <a:lnB w="6350" cap="flat" cmpd="sng" algn="ctr">
+                      <a:solidFill>
+                        <a:srgbClr val="E3DED7"/>
+                      </a:solidFill>
+                      <a:prstDash val="solid"/>
+                      <a:round/>
+                      <a:headEnd type="none" w="med" len="med"/>
+                      <a:tailEnd type="none" w="med" len="med"/>
+                    </a:lnB>
+                    <a:solidFill>
                       <a:srgbClr val="FFFFFF"/>
                     </a:solidFill>
                   </a:tcPr>
@@ -40165,7 +40269,7 @@
                             <a:srgbClr val="8A1626"/>
                           </a:solidFill>
                         </a:rPr>
-                        <a:t>2.7.0 AI</a:t>
+                        <a:t>2.8.0 AI</a:t>
                       </a:r>
                       <a:endParaRPr lang="en-US" sz="1350" dirty="0"/>
                     </a:p>
@@ -40226,7 +40330,7 @@
                             <a:srgbClr val="1A1A1A"/>
                           </a:solidFill>
                         </a:rPr>
-                        <a:t>GenUI (an agent composes a live screen from governed Sutra fragments) and AI management</a:t>
+                        <a:t>GenUI (an agent composes a live screen from governed Sutra fragments), AI management, the Sajha MCP connector</a:t>
                       </a:r>
                       <a:endParaRPr lang="en-US" sz="1350" dirty="0"/>
                     </a:p>
@@ -40535,7 +40639,7 @@
                             <a:srgbClr val="8A1626"/>
                           </a:solidFill>
                         </a:rPr>
-                        <a:t>2.8.0 Readiness</a:t>
+                        <a:t>2.9.0 Readiness</a:t>
                       </a:r>
                       <a:endParaRPr lang="en-US" sz="1350" dirty="0"/>
                     </a:p>
@@ -40905,7 +41009,7 @@
                             <a:srgbClr val="8A1626"/>
                           </a:solidFill>
                         </a:rPr>
-                        <a:t>Later candidates</a:t>
+                        <a:t>After 3.0</a:t>
                       </a:r>
                       <a:endParaRPr lang="en-US" sz="1350" dirty="0"/>
                     </a:p>
@@ -40966,7 +41070,7 @@
                             <a:srgbClr val="1A1A1A"/>
                           </a:solidFill>
                         </a:rPr>
-                        <a:t>Server-side pricing (QuantLib, ADR-019), Windows proven on a real machine</a:t>
+                        <a:t>Send and push (Outlook, Teams, SharePoint); integration (PG-wire, Excel feed, embed tokens, SDK events); pricing (ADR-019)</a:t>
                       </a:r>
                       <a:endParaRPr lang="en-US" sz="1350" dirty="0"/>
                     </a:p>
@@ -41027,7 +41131,7 @@
                             <a:srgbClr val="1A1A1A"/>
                           </a:solidFill>
                         </a:rPr>
-                        <a:t>Prices beside the data, explained</a:t>
+                        <a:t>Designed, not scheduled</a:t>
                       </a:r>
                       <a:endParaRPr lang="en-US" sz="1350" dirty="0"/>
                     </a:p>

</xml_diff>

<commit_message>
Design and Evidence deck: nineteen source plugins (three slides said 18)
</commit_message>
<xml_diff>
--- a/docs/publications/Drishti-Design-and-Evidence.pptx
+++ b/docs/publications/Drishti-Design-and-Evidence.pptx
@@ -6694,6 +6694,10 @@
           </a:solidFill>
           <a:ln/>
         </p:spPr>
+        <p:txBody>
+          <a:bodyPr/>
+          <a:p/>
+        </p:txBody>
       </p:sp>
       <p:sp>
         <p:nvSpPr>
@@ -7426,7 +7430,7 @@
                   <a:srgbClr val="4A5058"/>
                 </a:solidFill>
               </a:rPr>
-              <a:t>Virtual threads fetch in parallel; the engine matches a Sutra, merges inference, links ids and binds values; BI models answer on DuckDB — 18 source plugins</a:t>
+              <a:t>Virtual threads fetch in parallel; the engine matches a Sutra, merges inference, links ids and binds values; BI models answer on DuckDB — 19 source plugins</a:t>
             </a:r>
             <a:endParaRPr lang="en-US" sz="1200" dirty="0"/>
           </a:p>
@@ -7463,6 +7467,10 @@
             </a:outerShdw>
           </a:effectLst>
         </p:spPr>
+        <p:txBody>
+          <a:bodyPr/>
+          <a:p/>
+        </p:txBody>
       </p:sp>
       <p:sp>
         <p:nvSpPr>
@@ -7603,6 +7611,10 @@
             </a:outerShdw>
           </a:effectLst>
         </p:spPr>
+        <p:txBody>
+          <a:bodyPr/>
+          <a:p/>
+        </p:txBody>
       </p:sp>
       <p:sp>
         <p:nvSpPr>
@@ -7707,6 +7719,10 @@
             </a:outerShdw>
           </a:effectLst>
         </p:spPr>
+        <p:txBody>
+          <a:bodyPr/>
+          <a:p/>
+        </p:txBody>
       </p:sp>
       <p:sp>
         <p:nvSpPr>
@@ -7811,6 +7827,10 @@
             </a:outerShdw>
           </a:effectLst>
         </p:spPr>
+        <p:txBody>
+          <a:bodyPr/>
+          <a:p/>
+        </p:txBody>
       </p:sp>
       <p:sp>
         <p:nvSpPr>
@@ -7915,6 +7935,10 @@
             </a:outerShdw>
           </a:effectLst>
         </p:spPr>
+        <p:txBody>
+          <a:bodyPr/>
+          <a:p/>
+        </p:txBody>
       </p:sp>
       <p:sp>
         <p:nvSpPr>
@@ -8011,6 +8035,10 @@
             <a:tailEnd type="triangle"/>
           </a:ln>
         </p:spPr>
+        <p:txBody>
+          <a:bodyPr/>
+          <a:p/>
+        </p:txBody>
       </p:sp>
       <p:sp>
         <p:nvSpPr>
@@ -8035,6 +8063,10 @@
             <a:tailEnd type="triangle"/>
           </a:ln>
         </p:spPr>
+        <p:txBody>
+          <a:bodyPr/>
+          <a:p/>
+        </p:txBody>
       </p:sp>
       <p:sp>
         <p:nvSpPr>
@@ -8059,6 +8091,10 @@
             <a:tailEnd type="triangle"/>
           </a:ln>
         </p:spPr>
+        <p:txBody>
+          <a:bodyPr/>
+          <a:p/>
+        </p:txBody>
       </p:sp>
       <p:sp>
         <p:nvSpPr>
@@ -8225,6 +8261,10 @@
           </a:solidFill>
           <a:ln/>
         </p:spPr>
+        <p:txBody>
+          <a:bodyPr/>
+          <a:p/>
+        </p:txBody>
       </p:sp>
       <p:sp>
         <p:nvSpPr>
@@ -8245,6 +8285,10 @@
           </a:solidFill>
           <a:ln/>
         </p:spPr>
+        <p:txBody>
+          <a:bodyPr/>
+          <a:p/>
+        </p:txBody>
       </p:sp>
       <p:sp>
         <p:nvSpPr>
@@ -8301,6 +8345,10 @@
           </a:solidFill>
           <a:ln/>
         </p:spPr>
+        <p:txBody>
+          <a:bodyPr/>
+          <a:p/>
+        </p:txBody>
       </p:sp>
       <p:sp>
         <p:nvSpPr>
@@ -8393,6 +8441,10 @@
           </a:solidFill>
           <a:ln/>
         </p:spPr>
+        <p:txBody>
+          <a:bodyPr/>
+          <a:p/>
+        </p:txBody>
       </p:sp>
       <p:sp>
         <p:nvSpPr>
@@ -8449,6 +8501,10 @@
           </a:solidFill>
           <a:ln/>
         </p:spPr>
+        <p:txBody>
+          <a:bodyPr/>
+          <a:p/>
+        </p:txBody>
       </p:sp>
       <p:sp>
         <p:nvSpPr>
@@ -8541,6 +8597,10 @@
           </a:solidFill>
           <a:ln/>
         </p:spPr>
+        <p:txBody>
+          <a:bodyPr/>
+          <a:p/>
+        </p:txBody>
       </p:sp>
       <p:sp>
         <p:nvSpPr>
@@ -8597,6 +8657,10 @@
           </a:solidFill>
           <a:ln/>
         </p:spPr>
+        <p:txBody>
+          <a:bodyPr/>
+          <a:p/>
+        </p:txBody>
       </p:sp>
       <p:sp>
         <p:nvSpPr>
@@ -8689,6 +8753,10 @@
           </a:solidFill>
           <a:ln/>
         </p:spPr>
+        <p:txBody>
+          <a:bodyPr/>
+          <a:p/>
+        </p:txBody>
       </p:sp>
       <p:sp>
         <p:nvSpPr>
@@ -8745,6 +8813,10 @@
           </a:solidFill>
           <a:ln/>
         </p:spPr>
+        <p:txBody>
+          <a:bodyPr/>
+          <a:p/>
+        </p:txBody>
       </p:sp>
       <p:sp>
         <p:nvSpPr>
@@ -8837,6 +8909,10 @@
           </a:solidFill>
           <a:ln/>
         </p:spPr>
+        <p:txBody>
+          <a:bodyPr/>
+          <a:p/>
+        </p:txBody>
       </p:sp>
       <p:sp>
         <p:nvSpPr>
@@ -8893,6 +8969,10 @@
           </a:solidFill>
           <a:ln/>
         </p:spPr>
+        <p:txBody>
+          <a:bodyPr/>
+          <a:p/>
+        </p:txBody>
       </p:sp>
       <p:sp>
         <p:nvSpPr>
@@ -8985,6 +9065,10 @@
           </a:solidFill>
           <a:ln/>
         </p:spPr>
+        <p:txBody>
+          <a:bodyPr/>
+          <a:p/>
+        </p:txBody>
       </p:sp>
       <p:sp>
         <p:nvSpPr>
@@ -9041,6 +9125,10 @@
           </a:solidFill>
           <a:ln/>
         </p:spPr>
+        <p:txBody>
+          <a:bodyPr/>
+          <a:p/>
+        </p:txBody>
       </p:sp>
       <p:sp>
         <p:nvSpPr>
@@ -9133,6 +9221,10 @@
           </a:solidFill>
           <a:ln/>
         </p:spPr>
+        <p:txBody>
+          <a:bodyPr/>
+          <a:p/>
+        </p:txBody>
       </p:sp>
       <p:sp>
         <p:nvSpPr>
@@ -9189,6 +9281,10 @@
           </a:solidFill>
           <a:ln/>
         </p:spPr>
+        <p:txBody>
+          <a:bodyPr/>
+          <a:p/>
+        </p:txBody>
       </p:sp>
       <p:sp>
         <p:nvSpPr>
@@ -9281,6 +9377,10 @@
           </a:solidFill>
           <a:ln/>
         </p:spPr>
+        <p:txBody>
+          <a:bodyPr/>
+          <a:p/>
+        </p:txBody>
       </p:sp>
       <p:sp>
         <p:nvSpPr>
@@ -9301,6 +9401,10 @@
           </a:solidFill>
           <a:ln/>
         </p:spPr>
+        <p:txBody>
+          <a:bodyPr/>
+          <a:p/>
+        </p:txBody>
       </p:sp>
       <p:sp>
         <p:nvSpPr>
@@ -9393,6 +9497,10 @@
           </a:solidFill>
           <a:ln/>
         </p:spPr>
+        <p:txBody>
+          <a:bodyPr/>
+          <a:p/>
+        </p:txBody>
       </p:sp>
       <p:sp>
         <p:nvSpPr>
@@ -9413,6 +9521,10 @@
           </a:solidFill>
           <a:ln/>
         </p:spPr>
+        <p:txBody>
+          <a:bodyPr/>
+          <a:p/>
+        </p:txBody>
       </p:sp>
       <p:sp>
         <p:nvSpPr>
@@ -9505,6 +9617,10 @@
           </a:solidFill>
           <a:ln/>
         </p:spPr>
+        <p:txBody>
+          <a:bodyPr/>
+          <a:p/>
+        </p:txBody>
       </p:sp>
       <p:sp>
         <p:nvSpPr>
@@ -9525,6 +9641,10 @@
           </a:solidFill>
           <a:ln/>
         </p:spPr>
+        <p:txBody>
+          <a:bodyPr/>
+          <a:p/>
+        </p:txBody>
       </p:sp>
       <p:sp>
         <p:nvSpPr>
@@ -9617,6 +9737,10 @@
           </a:solidFill>
           <a:ln/>
         </p:spPr>
+        <p:txBody>
+          <a:bodyPr/>
+          <a:p/>
+        </p:txBody>
       </p:sp>
       <p:sp>
         <p:nvSpPr>
@@ -9637,6 +9761,10 @@
           </a:solidFill>
           <a:ln/>
         </p:spPr>
+        <p:txBody>
+          <a:bodyPr/>
+          <a:p/>
+        </p:txBody>
       </p:sp>
       <p:sp>
         <p:nvSpPr>
@@ -9850,6 +9978,10 @@
           </a:solidFill>
           <a:ln/>
         </p:spPr>
+        <p:txBody>
+          <a:bodyPr/>
+          <a:p/>
+        </p:txBody>
       </p:sp>
       <p:sp>
         <p:nvSpPr>
@@ -9870,6 +10002,10 @@
           </a:solidFill>
           <a:ln/>
         </p:spPr>
+        <p:txBody>
+          <a:bodyPr/>
+          <a:p/>
+        </p:txBody>
       </p:sp>
       <p:sp>
         <p:nvSpPr>
@@ -9890,6 +10026,10 @@
           </a:solidFill>
           <a:ln/>
         </p:spPr>
+        <p:txBody>
+          <a:bodyPr/>
+          <a:p/>
+        </p:txBody>
       </p:sp>
       <p:sp>
         <p:nvSpPr>
@@ -10560,6 +10700,10 @@
           </a:solidFill>
           <a:ln/>
         </p:spPr>
+        <p:txBody>
+          <a:bodyPr/>
+          <a:p/>
+        </p:txBody>
       </p:sp>
       <p:sp>
         <p:nvSpPr>
@@ -10592,6 +10736,10 @@
             </a:outerShdw>
           </a:effectLst>
         </p:spPr>
+        <p:txBody>
+          <a:bodyPr/>
+          <a:p/>
+        </p:txBody>
       </p:sp>
       <p:sp>
         <p:nvSpPr>
@@ -10696,6 +10844,10 @@
             </a:outerShdw>
           </a:effectLst>
         </p:spPr>
+        <p:txBody>
+          <a:bodyPr/>
+          <a:p/>
+        </p:txBody>
       </p:sp>
       <p:sp>
         <p:nvSpPr>
@@ -10792,6 +10944,10 @@
             <a:tailEnd type="triangle"/>
           </a:ln>
         </p:spPr>
+        <p:txBody>
+          <a:bodyPr/>
+          <a:p/>
+        </p:txBody>
       </p:sp>
       <p:sp>
         <p:nvSpPr>
@@ -10824,6 +10980,10 @@
             </a:outerShdw>
           </a:effectLst>
         </p:spPr>
+        <p:txBody>
+          <a:bodyPr/>
+          <a:p/>
+        </p:txBody>
       </p:sp>
       <p:sp>
         <p:nvSpPr>
@@ -10920,6 +11080,10 @@
             <a:tailEnd type="triangle"/>
           </a:ln>
         </p:spPr>
+        <p:txBody>
+          <a:bodyPr/>
+          <a:p/>
+        </p:txBody>
       </p:sp>
       <p:sp>
         <p:nvSpPr>
@@ -10952,6 +11116,10 @@
             </a:outerShdw>
           </a:effectLst>
         </p:spPr>
+        <p:txBody>
+          <a:bodyPr/>
+          <a:p/>
+        </p:txBody>
       </p:sp>
       <p:sp>
         <p:nvSpPr>
@@ -11048,6 +11216,10 @@
             <a:tailEnd type="triangle"/>
           </a:ln>
         </p:spPr>
+        <p:txBody>
+          <a:bodyPr/>
+          <a:p/>
+        </p:txBody>
       </p:sp>
       <p:sp>
         <p:nvSpPr>
@@ -11080,6 +11252,10 @@
             </a:outerShdw>
           </a:effectLst>
         </p:spPr>
+        <p:txBody>
+          <a:bodyPr/>
+          <a:p/>
+        </p:txBody>
       </p:sp>
       <p:sp>
         <p:nvSpPr>
@@ -11176,6 +11352,10 @@
             <a:tailEnd type="triangle"/>
           </a:ln>
         </p:spPr>
+        <p:txBody>
+          <a:bodyPr/>
+          <a:p/>
+        </p:txBody>
       </p:sp>
       <p:sp>
         <p:nvSpPr>
@@ -11196,6 +11376,10 @@
           </a:solidFill>
           <a:ln/>
         </p:spPr>
+        <p:txBody>
+          <a:bodyPr/>
+          <a:p/>
+        </p:txBody>
       </p:sp>
       <p:sp>
         <p:nvSpPr>
@@ -11216,6 +11400,10 @@
           </a:solidFill>
           <a:ln/>
         </p:spPr>
+        <p:txBody>
+          <a:bodyPr/>
+          <a:p/>
+        </p:txBody>
       </p:sp>
       <p:sp>
         <p:nvSpPr>
@@ -11308,6 +11496,10 @@
           </a:solidFill>
           <a:ln/>
         </p:spPr>
+        <p:txBody>
+          <a:bodyPr/>
+          <a:p/>
+        </p:txBody>
       </p:sp>
       <p:sp>
         <p:nvSpPr>
@@ -11328,6 +11520,10 @@
           </a:solidFill>
           <a:ln/>
         </p:spPr>
+        <p:txBody>
+          <a:bodyPr/>
+          <a:p/>
+        </p:txBody>
       </p:sp>
       <p:sp>
         <p:nvSpPr>
@@ -11420,6 +11616,10 @@
           </a:solidFill>
           <a:ln/>
         </p:spPr>
+        <p:txBody>
+          <a:bodyPr/>
+          <a:p/>
+        </p:txBody>
       </p:sp>
       <p:sp>
         <p:nvSpPr>
@@ -11440,6 +11640,10 @@
           </a:solidFill>
           <a:ln/>
         </p:spPr>
+        <p:txBody>
+          <a:bodyPr/>
+          <a:p/>
+        </p:txBody>
       </p:sp>
       <p:sp>
         <p:nvSpPr>
@@ -11532,6 +11736,10 @@
           </a:solidFill>
           <a:ln/>
         </p:spPr>
+        <p:txBody>
+          <a:bodyPr/>
+          <a:p/>
+        </p:txBody>
       </p:sp>
       <p:sp>
         <p:nvSpPr>
@@ -11552,6 +11760,10 @@
           </a:solidFill>
           <a:ln/>
         </p:spPr>
+        <p:txBody>
+          <a:bodyPr/>
+          <a:p/>
+        </p:txBody>
       </p:sp>
       <p:sp>
         <p:nvSpPr>
@@ -11644,6 +11856,10 @@
           </a:solidFill>
           <a:ln/>
         </p:spPr>
+        <p:txBody>
+          <a:bodyPr/>
+          <a:p/>
+        </p:txBody>
       </p:sp>
       <p:sp>
         <p:nvSpPr>
@@ -11664,6 +11880,10 @@
           </a:solidFill>
           <a:ln/>
         </p:spPr>
+        <p:txBody>
+          <a:bodyPr/>
+          <a:p/>
+        </p:txBody>
       </p:sp>
       <p:sp>
         <p:nvSpPr>
@@ -11877,6 +12097,10 @@
           </a:solidFill>
           <a:ln/>
         </p:spPr>
+        <p:txBody>
+          <a:bodyPr/>
+          <a:p/>
+        </p:txBody>
       </p:sp>
       <p:sp>
         <p:nvSpPr>
@@ -11902,6 +12126,10 @@
             <a:prstDash val="solid"/>
           </a:ln>
         </p:spPr>
+        <p:txBody>
+          <a:bodyPr/>
+          <a:p/>
+        </p:txBody>
       </p:sp>
       <p:sp>
         <p:nvSpPr>
@@ -11999,6 +12227,10 @@
             <a:prstDash val="solid"/>
           </a:ln>
         </p:spPr>
+        <p:txBody>
+          <a:bodyPr/>
+          <a:p/>
+        </p:txBody>
       </p:sp>
       <p:sp>
         <p:nvSpPr>
@@ -12096,6 +12328,10 @@
             <a:prstDash val="solid"/>
           </a:ln>
         </p:spPr>
+        <p:txBody>
+          <a:bodyPr/>
+          <a:p/>
+        </p:txBody>
       </p:sp>
       <p:sp>
         <p:nvSpPr>
@@ -12193,6 +12429,10 @@
             <a:prstDash val="solid"/>
           </a:ln>
         </p:spPr>
+        <p:txBody>
+          <a:bodyPr/>
+          <a:p/>
+        </p:txBody>
       </p:sp>
       <p:sp>
         <p:nvSpPr>
@@ -12290,6 +12530,10 @@
             <a:prstDash val="solid"/>
           </a:ln>
         </p:spPr>
+        <p:txBody>
+          <a:bodyPr/>
+          <a:p/>
+        </p:txBody>
       </p:sp>
       <p:sp>
         <p:nvSpPr>
@@ -12382,6 +12626,10 @@
           </a:solidFill>
           <a:ln/>
         </p:spPr>
+        <p:txBody>
+          <a:bodyPr/>
+          <a:p/>
+        </p:txBody>
       </p:sp>
       <p:sp>
         <p:nvSpPr>
@@ -12402,6 +12650,10 @@
           </a:solidFill>
           <a:ln/>
         </p:spPr>
+        <p:txBody>
+          <a:bodyPr/>
+          <a:p/>
+        </p:txBody>
       </p:sp>
       <p:sp>
         <p:nvSpPr>
@@ -12580,6 +12832,10 @@
             <a:prstDash val="solid"/>
           </a:ln>
         </p:spPr>
+        <p:txBody>
+          <a:bodyPr/>
+          <a:p/>
+        </p:txBody>
       </p:sp>
       <p:sp>
         <p:nvSpPr>
@@ -12605,6 +12861,10 @@
             <a:prstDash val="solid"/>
           </a:ln>
         </p:spPr>
+        <p:txBody>
+          <a:bodyPr/>
+          <a:p/>
+        </p:txBody>
       </p:sp>
       <p:sp>
         <p:nvSpPr>
@@ -12630,6 +12890,10 @@
             <a:prstDash val="solid"/>
           </a:ln>
         </p:spPr>
+        <p:txBody>
+          <a:bodyPr/>
+          <a:p/>
+        </p:txBody>
       </p:sp>
       <p:sp>
         <p:nvSpPr>
@@ -12650,6 +12914,10 @@
           </a:solidFill>
           <a:ln/>
         </p:spPr>
+        <p:txBody>
+          <a:bodyPr/>
+          <a:p/>
+        </p:txBody>
       </p:sp>
       <p:sp>
         <p:nvSpPr>
@@ -13684,6 +13952,10 @@
           </a:solidFill>
           <a:ln/>
         </p:spPr>
+        <p:txBody>
+          <a:bodyPr/>
+          <a:p/>
+        </p:txBody>
       </p:sp>
       <p:sp>
         <p:nvSpPr>
@@ -13716,6 +13988,10 @@
             </a:outerShdw>
           </a:effectLst>
         </p:spPr>
+        <p:txBody>
+          <a:bodyPr/>
+          <a:p/>
+        </p:txBody>
       </p:sp>
       <p:pic>
         <p:nvPicPr>
@@ -14088,6 +14364,10 @@
           </a:solidFill>
           <a:ln/>
         </p:spPr>
+        <p:txBody>
+          <a:bodyPr/>
+          <a:p/>
+        </p:txBody>
       </p:sp>
       <p:sp>
         <p:nvSpPr>
@@ -14120,6 +14400,10 @@
             </a:outerShdw>
           </a:effectLst>
         </p:spPr>
+        <p:txBody>
+          <a:bodyPr/>
+          <a:p/>
+        </p:txBody>
       </p:sp>
       <p:pic>
         <p:nvPicPr>
@@ -14456,6 +14740,10 @@
           </a:solidFill>
           <a:ln/>
         </p:spPr>
+        <p:txBody>
+          <a:bodyPr/>
+          <a:p/>
+        </p:txBody>
       </p:sp>
       <p:sp>
         <p:nvSpPr>
@@ -14488,6 +14776,10 @@
             </a:outerShdw>
           </a:effectLst>
         </p:spPr>
+        <p:txBody>
+          <a:bodyPr/>
+          <a:p/>
+        </p:txBody>
       </p:sp>
       <p:pic>
         <p:nvPicPr>
@@ -14824,6 +15116,10 @@
           </a:solidFill>
           <a:ln/>
         </p:spPr>
+        <p:txBody>
+          <a:bodyPr/>
+          <a:p/>
+        </p:txBody>
       </p:sp>
       <p:sp>
         <p:nvSpPr>
@@ -14844,6 +15140,10 @@
           </a:solidFill>
           <a:ln/>
         </p:spPr>
+        <p:txBody>
+          <a:bodyPr/>
+          <a:p/>
+        </p:txBody>
       </p:sp>
       <p:sp>
         <p:nvSpPr>
@@ -14864,6 +15164,10 @@
           </a:solidFill>
           <a:ln/>
         </p:spPr>
+        <p:txBody>
+          <a:bodyPr/>
+          <a:p/>
+        </p:txBody>
       </p:sp>
       <p:sp>
         <p:nvSpPr>
@@ -14884,6 +15188,10 @@
           </a:solidFill>
           <a:ln/>
         </p:spPr>
+        <p:txBody>
+          <a:bodyPr/>
+          <a:p/>
+        </p:txBody>
       </p:sp>
       <p:sp>
         <p:nvSpPr>
@@ -14976,6 +15284,10 @@
           </a:solidFill>
           <a:ln/>
         </p:spPr>
+        <p:txBody>
+          <a:bodyPr/>
+          <a:p/>
+        </p:txBody>
       </p:sp>
       <p:sp>
         <p:nvSpPr>
@@ -14996,6 +15308,10 @@
           </a:solidFill>
           <a:ln/>
         </p:spPr>
+        <p:txBody>
+          <a:bodyPr/>
+          <a:p/>
+        </p:txBody>
       </p:sp>
       <p:sp>
         <p:nvSpPr>
@@ -15016,6 +15332,10 @@
           </a:solidFill>
           <a:ln/>
         </p:spPr>
+        <p:txBody>
+          <a:bodyPr/>
+          <a:p/>
+        </p:txBody>
       </p:sp>
       <p:sp>
         <p:nvSpPr>
@@ -15108,6 +15428,10 @@
           </a:solidFill>
           <a:ln/>
         </p:spPr>
+        <p:txBody>
+          <a:bodyPr/>
+          <a:p/>
+        </p:txBody>
       </p:sp>
       <p:sp>
         <p:nvSpPr>
@@ -15128,6 +15452,10 @@
           </a:solidFill>
           <a:ln/>
         </p:spPr>
+        <p:txBody>
+          <a:bodyPr/>
+          <a:p/>
+        </p:txBody>
       </p:sp>
       <p:sp>
         <p:nvSpPr>
@@ -15148,6 +15476,10 @@
           </a:solidFill>
           <a:ln/>
         </p:spPr>
+        <p:txBody>
+          <a:bodyPr/>
+          <a:p/>
+        </p:txBody>
       </p:sp>
       <p:sp>
         <p:nvSpPr>
@@ -15240,6 +15572,10 @@
           </a:solidFill>
           <a:ln/>
         </p:spPr>
+        <p:txBody>
+          <a:bodyPr/>
+          <a:p/>
+        </p:txBody>
       </p:sp>
       <p:sp>
         <p:nvSpPr>
@@ -15260,6 +15596,10 @@
           </a:solidFill>
           <a:ln/>
         </p:spPr>
+        <p:txBody>
+          <a:bodyPr/>
+          <a:p/>
+        </p:txBody>
       </p:sp>
       <p:sp>
         <p:nvSpPr>
@@ -15280,6 +15620,10 @@
           </a:solidFill>
           <a:ln/>
         </p:spPr>
+        <p:txBody>
+          <a:bodyPr/>
+          <a:p/>
+        </p:txBody>
       </p:sp>
       <p:sp>
         <p:nvSpPr>
@@ -15347,7 +15691,7 @@
                   <a:srgbClr val="1A1A1A"/>
                 </a:solidFill>
               </a:rPr>
-              <a:t>Release 2.5 and 2.6 so far: 7 packs, 197 Sutras, 22 panel kinds, 18 source plugins, BI Studio with statements, Python data prep, several servers as one (Drishti*net); 35.7 million trades served to 50 users at 179 requests/s.</a:t>
+              <a:t>Release 2.5 and 2.6 so far: 7 packs, 197 Sutras, 22 panel kinds, 19 source plugins, BI Studio with statements, Python data prep, several servers as one (Drishti*net); 35.7 million trades served to 50 users at 179 requests/s.</a:t>
             </a:r>
             <a:endParaRPr lang="en-US" sz="1300" dirty="0"/>
           </a:p>
@@ -15372,6 +15716,10 @@
           </a:solidFill>
           <a:ln/>
         </p:spPr>
+        <p:txBody>
+          <a:bodyPr/>
+          <a:p/>
+        </p:txBody>
       </p:sp>
       <p:sp>
         <p:nvSpPr>
@@ -15392,6 +15740,10 @@
           </a:solidFill>
           <a:ln/>
         </p:spPr>
+        <p:txBody>
+          <a:bodyPr/>
+          <a:p/>
+        </p:txBody>
       </p:sp>
       <p:sp>
         <p:nvSpPr>
@@ -15412,6 +15764,10 @@
           </a:solidFill>
           <a:ln/>
         </p:spPr>
+        <p:txBody>
+          <a:bodyPr/>
+          <a:p/>
+        </p:txBody>
       </p:sp>
       <p:sp>
         <p:nvSpPr>
@@ -15650,6 +16006,10 @@
           </a:solidFill>
           <a:ln/>
         </p:spPr>
+        <p:txBody>
+          <a:bodyPr/>
+          <a:p/>
+        </p:txBody>
       </p:sp>
       <p:sp>
         <p:nvSpPr>
@@ -15675,6 +16035,10 @@
             <a:prstDash val="solid"/>
           </a:ln>
         </p:spPr>
+        <p:txBody>
+          <a:bodyPr/>
+          <a:p/>
+        </p:txBody>
       </p:sp>
       <p:sp>
         <p:nvSpPr>
@@ -15772,6 +16136,10 @@
             <a:prstDash val="solid"/>
           </a:ln>
         </p:spPr>
+        <p:txBody>
+          <a:bodyPr/>
+          <a:p/>
+        </p:txBody>
       </p:sp>
       <p:sp>
         <p:nvSpPr>
@@ -15869,6 +16237,10 @@
             <a:prstDash val="solid"/>
           </a:ln>
         </p:spPr>
+        <p:txBody>
+          <a:bodyPr/>
+          <a:p/>
+        </p:txBody>
       </p:sp>
       <p:sp>
         <p:nvSpPr>
@@ -15966,6 +16338,10 @@
             <a:prstDash val="solid"/>
           </a:ln>
         </p:spPr>
+        <p:txBody>
+          <a:bodyPr/>
+          <a:p/>
+        </p:txBody>
       </p:sp>
       <p:sp>
         <p:nvSpPr>
@@ -16063,6 +16439,10 @@
             <a:prstDash val="solid"/>
           </a:ln>
         </p:spPr>
+        <p:txBody>
+          <a:bodyPr/>
+          <a:p/>
+        </p:txBody>
       </p:sp>
       <p:sp>
         <p:nvSpPr>
@@ -16155,6 +16535,10 @@
           </a:solidFill>
           <a:ln/>
         </p:spPr>
+        <p:txBody>
+          <a:bodyPr/>
+          <a:p/>
+        </p:txBody>
       </p:sp>
       <p:sp>
         <p:nvSpPr>
@@ -16175,6 +16559,10 @@
           </a:solidFill>
           <a:ln/>
         </p:spPr>
+        <p:txBody>
+          <a:bodyPr/>
+          <a:p/>
+        </p:txBody>
       </p:sp>
       <p:sp>
         <p:nvSpPr>
@@ -16388,6 +16776,10 @@
           </a:solidFill>
           <a:ln/>
         </p:spPr>
+        <p:txBody>
+          <a:bodyPr/>
+          <a:p/>
+        </p:txBody>
       </p:sp>
       <p:sp>
         <p:nvSpPr>
@@ -16420,6 +16812,10 @@
             </a:outerShdw>
           </a:effectLst>
         </p:spPr>
+        <p:txBody>
+          <a:bodyPr/>
+          <a:p/>
+        </p:txBody>
       </p:sp>
       <p:pic>
         <p:nvPicPr>
@@ -16756,6 +17152,10 @@
           </a:solidFill>
           <a:ln/>
         </p:spPr>
+        <p:txBody>
+          <a:bodyPr/>
+          <a:p/>
+        </p:txBody>
       </p:sp>
       <p:sp>
         <p:nvSpPr>
@@ -16788,6 +17188,10 @@
             </a:outerShdw>
           </a:effectLst>
         </p:spPr>
+        <p:txBody>
+          <a:bodyPr/>
+          <a:p/>
+        </p:txBody>
       </p:sp>
       <p:pic>
         <p:nvPicPr>
@@ -17124,6 +17528,10 @@
           </a:solidFill>
           <a:ln/>
         </p:spPr>
+        <p:txBody>
+          <a:bodyPr/>
+          <a:p/>
+        </p:txBody>
       </p:sp>
       <p:sp>
         <p:nvSpPr>
@@ -17156,6 +17564,10 @@
             </a:outerShdw>
           </a:effectLst>
         </p:spPr>
+        <p:txBody>
+          <a:bodyPr/>
+          <a:p/>
+        </p:txBody>
       </p:sp>
       <p:pic>
         <p:nvPicPr>
@@ -17200,6 +17612,10 @@
           </a:solidFill>
           <a:ln/>
         </p:spPr>
+        <p:txBody>
+          <a:bodyPr/>
+          <a:p/>
+        </p:txBody>
       </p:sp>
       <p:sp>
         <p:nvSpPr>
@@ -17302,6 +17718,10 @@
           </a:solidFill>
           <a:ln/>
         </p:spPr>
+        <p:txBody>
+          <a:bodyPr/>
+          <a:p/>
+        </p:txBody>
       </p:sp>
       <p:sp>
         <p:nvSpPr>
@@ -17322,6 +17742,10 @@
           </a:solidFill>
           <a:ln/>
         </p:spPr>
+        <p:txBody>
+          <a:bodyPr/>
+          <a:p/>
+        </p:txBody>
       </p:sp>
       <p:sp>
         <p:nvSpPr>
@@ -17414,6 +17838,10 @@
           </a:solidFill>
           <a:ln/>
         </p:spPr>
+        <p:txBody>
+          <a:bodyPr/>
+          <a:p/>
+        </p:txBody>
       </p:sp>
       <p:sp>
         <p:nvSpPr>
@@ -17434,6 +17862,10 @@
           </a:solidFill>
           <a:ln/>
         </p:spPr>
+        <p:txBody>
+          <a:bodyPr/>
+          <a:p/>
+        </p:txBody>
       </p:sp>
       <p:sp>
         <p:nvSpPr>
@@ -17562,6 +17994,10 @@
           </a:solidFill>
           <a:ln/>
         </p:spPr>
+        <p:txBody>
+          <a:bodyPr/>
+          <a:p/>
+        </p:txBody>
       </p:sp>
       <p:sp>
         <p:nvSpPr>
@@ -17582,6 +18018,10 @@
           </a:solidFill>
           <a:ln/>
         </p:spPr>
+        <p:txBody>
+          <a:bodyPr/>
+          <a:p/>
+        </p:txBody>
       </p:sp>
       <p:sp>
         <p:nvSpPr>
@@ -17795,6 +18235,10 @@
           </a:solidFill>
           <a:ln/>
         </p:spPr>
+        <p:txBody>
+          <a:bodyPr/>
+          <a:p/>
+        </p:txBody>
       </p:sp>
       <p:sp>
         <p:nvSpPr>
@@ -17827,6 +18271,10 @@
             </a:outerShdw>
           </a:effectLst>
         </p:spPr>
+        <p:txBody>
+          <a:bodyPr/>
+          <a:p/>
+        </p:txBody>
       </p:sp>
       <p:pic>
         <p:nvPicPr>
@@ -17883,6 +18331,10 @@
             </a:outerShdw>
           </a:effectLst>
         </p:spPr>
+        <p:txBody>
+          <a:bodyPr/>
+          <a:p/>
+        </p:txBody>
       </p:sp>
       <p:pic>
         <p:nvPicPr>
@@ -17999,6 +18451,10 @@
           </a:solidFill>
           <a:ln/>
         </p:spPr>
+        <p:txBody>
+          <a:bodyPr/>
+          <a:p/>
+        </p:txBody>
       </p:sp>
       <p:sp>
         <p:nvSpPr>
@@ -18019,6 +18475,10 @@
           </a:solidFill>
           <a:ln/>
         </p:spPr>
+        <p:txBody>
+          <a:bodyPr/>
+          <a:p/>
+        </p:txBody>
       </p:sp>
       <p:sp>
         <p:nvSpPr>
@@ -18232,6 +18692,10 @@
           </a:solidFill>
           <a:ln/>
         </p:spPr>
+        <p:txBody>
+          <a:bodyPr/>
+          <a:p/>
+        </p:txBody>
       </p:sp>
       <p:sp>
         <p:nvSpPr>
@@ -18264,6 +18728,10 @@
             </a:outerShdw>
           </a:effectLst>
         </p:spPr>
+        <p:txBody>
+          <a:bodyPr/>
+          <a:p/>
+        </p:txBody>
       </p:sp>
       <p:pic>
         <p:nvPicPr>
@@ -18308,6 +18776,10 @@
           </a:solidFill>
           <a:ln/>
         </p:spPr>
+        <p:txBody>
+          <a:bodyPr/>
+          <a:p/>
+        </p:txBody>
       </p:sp>
       <p:sp>
         <p:nvSpPr>
@@ -18671,6 +19143,10 @@
           </a:solidFill>
           <a:ln/>
         </p:spPr>
+        <p:txBody>
+          <a:bodyPr/>
+          <a:p/>
+        </p:txBody>
       </p:sp>
       <p:sp>
         <p:nvSpPr>
@@ -18691,6 +19167,10 @@
           </a:solidFill>
           <a:ln/>
         </p:spPr>
+        <p:txBody>
+          <a:bodyPr/>
+          <a:p/>
+        </p:txBody>
       </p:sp>
       <p:sp>
         <p:nvSpPr>
@@ -18711,6 +19191,10 @@
           </a:solidFill>
           <a:ln/>
         </p:spPr>
+        <p:txBody>
+          <a:bodyPr/>
+          <a:p/>
+        </p:txBody>
       </p:sp>
       <p:sp>
         <p:nvSpPr>
@@ -18921,6 +19405,10 @@
             </a:outerShdw>
           </a:effectLst>
         </p:spPr>
+        <p:txBody>
+          <a:bodyPr/>
+          <a:p/>
+        </p:txBody>
       </p:sp>
       <p:pic>
         <p:nvPicPr>
@@ -19049,6 +19537,10 @@
           </a:solidFill>
           <a:ln/>
         </p:spPr>
+        <p:txBody>
+          <a:bodyPr/>
+          <a:p/>
+        </p:txBody>
       </p:sp>
       <p:sp>
         <p:nvSpPr>
@@ -19069,6 +19561,10 @@
           </a:solidFill>
           <a:ln/>
         </p:spPr>
+        <p:txBody>
+          <a:bodyPr/>
+          <a:p/>
+        </p:txBody>
       </p:sp>
       <p:sp>
         <p:nvSpPr>
@@ -19282,6 +19778,10 @@
           </a:solidFill>
           <a:ln/>
         </p:spPr>
+        <p:txBody>
+          <a:bodyPr/>
+          <a:p/>
+        </p:txBody>
       </p:sp>
       <p:graphicFrame>
         <p:nvGraphicFramePr>
@@ -20628,6 +21128,10 @@
           </a:solidFill>
           <a:ln/>
         </p:spPr>
+        <p:txBody>
+          <a:bodyPr/>
+          <a:p/>
+        </p:txBody>
       </p:sp>
       <p:sp>
         <p:nvSpPr>
@@ -20648,6 +21152,10 @@
           </a:solidFill>
           <a:ln/>
         </p:spPr>
+        <p:txBody>
+          <a:bodyPr/>
+          <a:p/>
+        </p:txBody>
       </p:sp>
       <p:sp>
         <p:nvSpPr>
@@ -20861,6 +21369,10 @@
           </a:solidFill>
           <a:ln/>
         </p:spPr>
+        <p:txBody>
+          <a:bodyPr/>
+          <a:p/>
+        </p:txBody>
       </p:sp>
       <p:sp>
         <p:nvSpPr>
@@ -20881,6 +21393,10 @@
           </a:solidFill>
           <a:ln/>
         </p:spPr>
+        <p:txBody>
+          <a:bodyPr/>
+          <a:p/>
+        </p:txBody>
       </p:sp>
       <p:sp>
         <p:nvSpPr>
@@ -21044,6 +21560,10 @@
             </a:outerShdw>
           </a:effectLst>
         </p:spPr>
+        <p:txBody>
+          <a:bodyPr/>
+          <a:p/>
+        </p:txBody>
       </p:sp>
       <p:pic>
         <p:nvPicPr>
@@ -21124,6 +21644,10 @@
           </a:solidFill>
           <a:ln/>
         </p:spPr>
+        <p:txBody>
+          <a:bodyPr/>
+          <a:p/>
+        </p:txBody>
       </p:sp>
       <p:sp>
         <p:nvSpPr>
@@ -21144,6 +21668,10 @@
           </a:solidFill>
           <a:ln/>
         </p:spPr>
+        <p:txBody>
+          <a:bodyPr/>
+          <a:p/>
+        </p:txBody>
       </p:sp>
       <p:sp>
         <p:nvSpPr>
@@ -21236,6 +21764,10 @@
           </a:solidFill>
           <a:ln/>
         </p:spPr>
+        <p:txBody>
+          <a:bodyPr/>
+          <a:p/>
+        </p:txBody>
       </p:sp>
       <p:sp>
         <p:nvSpPr>
@@ -21256,6 +21788,10 @@
           </a:solidFill>
           <a:ln/>
         </p:spPr>
+        <p:txBody>
+          <a:bodyPr/>
+          <a:p/>
+        </p:txBody>
       </p:sp>
       <p:sp>
         <p:nvSpPr>
@@ -21348,6 +21884,10 @@
           </a:solidFill>
           <a:ln/>
         </p:spPr>
+        <p:txBody>
+          <a:bodyPr/>
+          <a:p/>
+        </p:txBody>
       </p:sp>
       <p:sp>
         <p:nvSpPr>
@@ -21368,6 +21908,10 @@
           </a:solidFill>
           <a:ln/>
         </p:spPr>
+        <p:txBody>
+          <a:bodyPr/>
+          <a:p/>
+        </p:txBody>
       </p:sp>
       <p:sp>
         <p:nvSpPr>
@@ -21460,6 +22004,10 @@
           </a:solidFill>
           <a:ln/>
         </p:spPr>
+        <p:txBody>
+          <a:bodyPr/>
+          <a:p/>
+        </p:txBody>
       </p:sp>
       <p:sp>
         <p:nvSpPr>
@@ -21480,6 +22028,10 @@
           </a:solidFill>
           <a:ln/>
         </p:spPr>
+        <p:txBody>
+          <a:bodyPr/>
+          <a:p/>
+        </p:txBody>
       </p:sp>
       <p:sp>
         <p:nvSpPr>
@@ -21572,6 +22124,10 @@
           </a:solidFill>
           <a:ln/>
         </p:spPr>
+        <p:txBody>
+          <a:bodyPr/>
+          <a:p/>
+        </p:txBody>
       </p:sp>
       <p:sp>
         <p:nvSpPr>
@@ -21592,6 +22148,10 @@
           </a:solidFill>
           <a:ln/>
         </p:spPr>
+        <p:txBody>
+          <a:bodyPr/>
+          <a:p/>
+        </p:txBody>
       </p:sp>
       <p:sp>
         <p:nvSpPr>
@@ -21805,6 +22365,10 @@
           </a:solidFill>
           <a:ln/>
         </p:spPr>
+        <p:txBody>
+          <a:bodyPr/>
+          <a:p/>
+        </p:txBody>
       </p:sp>
       <p:sp>
         <p:nvSpPr>
@@ -21837,6 +22401,10 @@
             </a:outerShdw>
           </a:effectLst>
         </p:spPr>
+        <p:txBody>
+          <a:bodyPr/>
+          <a:p/>
+        </p:txBody>
       </p:sp>
       <p:sp>
         <p:nvSpPr>
@@ -21941,6 +22509,10 @@
             </a:outerShdw>
           </a:effectLst>
         </p:spPr>
+        <p:txBody>
+          <a:bodyPr/>
+          <a:p/>
+        </p:txBody>
       </p:sp>
       <p:sp>
         <p:nvSpPr>
@@ -22037,6 +22609,10 @@
             <a:tailEnd type="triangle"/>
           </a:ln>
         </p:spPr>
+        <p:txBody>
+          <a:bodyPr/>
+          <a:p/>
+        </p:txBody>
       </p:sp>
       <p:sp>
         <p:nvSpPr>
@@ -22069,6 +22645,10 @@
             </a:outerShdw>
           </a:effectLst>
         </p:spPr>
+        <p:txBody>
+          <a:bodyPr/>
+          <a:p/>
+        </p:txBody>
       </p:sp>
       <p:sp>
         <p:nvSpPr>
@@ -22165,6 +22745,10 @@
             <a:tailEnd type="triangle"/>
           </a:ln>
         </p:spPr>
+        <p:txBody>
+          <a:bodyPr/>
+          <a:p/>
+        </p:txBody>
       </p:sp>
       <p:sp>
         <p:nvSpPr>
@@ -22197,6 +22781,10 @@
             </a:outerShdw>
           </a:effectLst>
         </p:spPr>
+        <p:txBody>
+          <a:bodyPr/>
+          <a:p/>
+        </p:txBody>
       </p:sp>
       <p:sp>
         <p:nvSpPr>
@@ -22293,6 +22881,10 @@
             <a:tailEnd type="triangle"/>
           </a:ln>
         </p:spPr>
+        <p:txBody>
+          <a:bodyPr/>
+          <a:p/>
+        </p:txBody>
       </p:sp>
       <p:sp>
         <p:nvSpPr>
@@ -22325,6 +22917,10 @@
             </a:outerShdw>
           </a:effectLst>
         </p:spPr>
+        <p:txBody>
+          <a:bodyPr/>
+          <a:p/>
+        </p:txBody>
       </p:sp>
       <p:sp>
         <p:nvSpPr>
@@ -22421,6 +23017,10 @@
             <a:tailEnd type="triangle"/>
           </a:ln>
         </p:spPr>
+        <p:txBody>
+          <a:bodyPr/>
+          <a:p/>
+        </p:txBody>
       </p:sp>
       <p:sp>
         <p:nvSpPr>
@@ -22441,6 +23041,10 @@
           </a:solidFill>
           <a:ln/>
         </p:spPr>
+        <p:txBody>
+          <a:bodyPr/>
+          <a:p/>
+        </p:txBody>
       </p:sp>
       <p:sp>
         <p:nvSpPr>
@@ -22461,6 +23065,10 @@
           </a:solidFill>
           <a:ln/>
         </p:spPr>
+        <p:txBody>
+          <a:bodyPr/>
+          <a:p/>
+        </p:txBody>
       </p:sp>
       <p:sp>
         <p:nvSpPr>
@@ -22553,6 +23161,10 @@
           </a:solidFill>
           <a:ln/>
         </p:spPr>
+        <p:txBody>
+          <a:bodyPr/>
+          <a:p/>
+        </p:txBody>
       </p:sp>
       <p:sp>
         <p:nvSpPr>
@@ -22573,6 +23185,10 @@
           </a:solidFill>
           <a:ln/>
         </p:spPr>
+        <p:txBody>
+          <a:bodyPr/>
+          <a:p/>
+        </p:txBody>
       </p:sp>
       <p:sp>
         <p:nvSpPr>
@@ -22665,6 +23281,10 @@
           </a:solidFill>
           <a:ln/>
         </p:spPr>
+        <p:txBody>
+          <a:bodyPr/>
+          <a:p/>
+        </p:txBody>
       </p:sp>
       <p:sp>
         <p:nvSpPr>
@@ -22685,6 +23305,10 @@
           </a:solidFill>
           <a:ln/>
         </p:spPr>
+        <p:txBody>
+          <a:bodyPr/>
+          <a:p/>
+        </p:txBody>
       </p:sp>
       <p:sp>
         <p:nvSpPr>
@@ -22777,6 +23401,10 @@
           </a:solidFill>
           <a:ln/>
         </p:spPr>
+        <p:txBody>
+          <a:bodyPr/>
+          <a:p/>
+        </p:txBody>
       </p:sp>
       <p:sp>
         <p:nvSpPr>
@@ -22797,6 +23425,10 @@
           </a:solidFill>
           <a:ln/>
         </p:spPr>
+        <p:txBody>
+          <a:bodyPr/>
+          <a:p/>
+        </p:txBody>
       </p:sp>
       <p:sp>
         <p:nvSpPr>
@@ -22913,6 +23545,10 @@
           </a:solidFill>
           <a:ln/>
         </p:spPr>
+        <p:txBody>
+          <a:bodyPr/>
+          <a:p/>
+        </p:txBody>
       </p:sp>
       <p:sp>
         <p:nvSpPr>
@@ -22933,6 +23569,10 @@
           </a:solidFill>
           <a:ln/>
         </p:spPr>
+        <p:txBody>
+          <a:bodyPr/>
+          <a:p/>
+        </p:txBody>
       </p:sp>
       <p:sp>
         <p:nvSpPr>
@@ -23111,6 +23751,10 @@
             <a:prstDash val="solid"/>
           </a:ln>
         </p:spPr>
+        <p:txBody>
+          <a:bodyPr/>
+          <a:p/>
+        </p:txBody>
       </p:sp>
       <p:sp>
         <p:nvSpPr>
@@ -23136,6 +23780,10 @@
             <a:prstDash val="solid"/>
           </a:ln>
         </p:spPr>
+        <p:txBody>
+          <a:bodyPr/>
+          <a:p/>
+        </p:txBody>
       </p:sp>
       <p:sp>
         <p:nvSpPr>
@@ -23161,6 +23809,10 @@
             <a:prstDash val="solid"/>
           </a:ln>
         </p:spPr>
+        <p:txBody>
+          <a:bodyPr/>
+          <a:p/>
+        </p:txBody>
       </p:sp>
       <p:sp>
         <p:nvSpPr>
@@ -23181,6 +23833,10 @@
           </a:solidFill>
           <a:ln/>
         </p:spPr>
+        <p:txBody>
+          <a:bodyPr/>
+          <a:p/>
+        </p:txBody>
       </p:sp>
       <p:sp>
         <p:nvSpPr>
@@ -23419,6 +24075,10 @@
           </a:solidFill>
           <a:ln/>
         </p:spPr>
+        <p:txBody>
+          <a:bodyPr/>
+          <a:p/>
+        </p:txBody>
       </p:sp>
       <p:sp>
         <p:nvSpPr>
@@ -23451,6 +24111,10 @@
             </a:outerShdw>
           </a:effectLst>
         </p:spPr>
+        <p:txBody>
+          <a:bodyPr/>
+          <a:p/>
+        </p:txBody>
       </p:sp>
       <p:pic>
         <p:nvPicPr>
@@ -23543,6 +24207,10 @@
             </a:outerShdw>
           </a:effectLst>
         </p:spPr>
+        <p:txBody>
+          <a:bodyPr/>
+          <a:p/>
+        </p:txBody>
       </p:sp>
       <p:pic>
         <p:nvPicPr>
@@ -23635,6 +24303,10 @@
             </a:outerShdw>
           </a:effectLst>
         </p:spPr>
+        <p:txBody>
+          <a:bodyPr/>
+          <a:p/>
+        </p:txBody>
       </p:sp>
       <p:pic>
         <p:nvPicPr>
@@ -23727,6 +24399,10 @@
             </a:outerShdw>
           </a:effectLst>
         </p:spPr>
+        <p:txBody>
+          <a:bodyPr/>
+          <a:p/>
+        </p:txBody>
       </p:sp>
       <p:pic>
         <p:nvPicPr>
@@ -24033,6 +24709,10 @@
             <a:prstDash val="solid"/>
           </a:ln>
         </p:spPr>
+        <p:txBody>
+          <a:bodyPr/>
+          <a:p/>
+        </p:txBody>
       </p:sp>
       <p:sp>
         <p:nvSpPr>
@@ -24058,6 +24738,10 @@
             <a:prstDash val="solid"/>
           </a:ln>
         </p:spPr>
+        <p:txBody>
+          <a:bodyPr/>
+          <a:p/>
+        </p:txBody>
       </p:sp>
       <p:sp>
         <p:nvSpPr>
@@ -24083,6 +24767,10 @@
             <a:prstDash val="solid"/>
           </a:ln>
         </p:spPr>
+        <p:txBody>
+          <a:bodyPr/>
+          <a:p/>
+        </p:txBody>
       </p:sp>
       <p:sp>
         <p:nvSpPr>
@@ -24103,6 +24791,10 @@
           </a:solidFill>
           <a:ln/>
         </p:spPr>
+        <p:txBody>
+          <a:bodyPr/>
+          <a:p/>
+        </p:txBody>
       </p:sp>
       <p:sp>
         <p:nvSpPr>
@@ -24341,6 +25033,10 @@
           </a:solidFill>
           <a:ln/>
         </p:spPr>
+        <p:txBody>
+          <a:bodyPr/>
+          <a:p/>
+        </p:txBody>
       </p:sp>
       <p:sp>
         <p:nvSpPr>
@@ -24361,6 +25057,10 @@
           </a:solidFill>
           <a:ln/>
         </p:spPr>
+        <p:txBody>
+          <a:bodyPr/>
+          <a:p/>
+        </p:txBody>
       </p:sp>
       <p:sp>
         <p:nvSpPr>
@@ -24381,6 +25081,10 @@
           </a:solidFill>
           <a:ln/>
         </p:spPr>
+        <p:txBody>
+          <a:bodyPr/>
+          <a:p/>
+        </p:txBody>
       </p:sp>
       <p:sp>
         <p:nvSpPr>
@@ -24545,6 +25249,10 @@
           </a:solidFill>
           <a:ln/>
         </p:spPr>
+        <p:txBody>
+          <a:bodyPr/>
+          <a:p/>
+        </p:txBody>
       </p:sp>
       <p:sp>
         <p:nvSpPr>
@@ -24565,6 +25273,10 @@
           </a:solidFill>
           <a:ln/>
         </p:spPr>
+        <p:txBody>
+          <a:bodyPr/>
+          <a:p/>
+        </p:txBody>
       </p:sp>
       <p:sp>
         <p:nvSpPr>
@@ -24729,6 +25441,10 @@
           </a:solidFill>
           <a:ln/>
         </p:spPr>
+        <p:txBody>
+          <a:bodyPr/>
+          <a:p/>
+        </p:txBody>
       </p:sp>
       <p:sp>
         <p:nvSpPr>
@@ -24749,6 +25465,10 @@
           </a:solidFill>
           <a:ln/>
         </p:spPr>
+        <p:txBody>
+          <a:bodyPr/>
+          <a:p/>
+        </p:txBody>
       </p:sp>
       <p:sp>
         <p:nvSpPr>
@@ -24913,6 +25633,10 @@
           </a:solidFill>
           <a:ln/>
         </p:spPr>
+        <p:txBody>
+          <a:bodyPr/>
+          <a:p/>
+        </p:txBody>
       </p:sp>
       <p:sp>
         <p:nvSpPr>
@@ -24933,6 +25657,10 @@
           </a:solidFill>
           <a:ln/>
         </p:spPr>
+        <p:txBody>
+          <a:bodyPr/>
+          <a:p/>
+        </p:txBody>
       </p:sp>
       <p:sp>
         <p:nvSpPr>
@@ -25591,6 +26319,10 @@
           </a:solidFill>
           <a:ln/>
         </p:spPr>
+        <p:txBody>
+          <a:bodyPr/>
+          <a:p/>
+        </p:txBody>
       </p:sp>
       <p:sp>
         <p:nvSpPr>
@@ -25611,6 +26343,10 @@
           </a:solidFill>
           <a:ln/>
         </p:spPr>
+        <p:txBody>
+          <a:bodyPr/>
+          <a:p/>
+        </p:txBody>
       </p:sp>
       <p:sp>
         <p:nvSpPr>
@@ -25824,6 +26560,10 @@
           </a:solidFill>
           <a:ln/>
         </p:spPr>
+        <p:txBody>
+          <a:bodyPr/>
+          <a:p/>
+        </p:txBody>
       </p:sp>
       <p:graphicFrame>
         <p:nvGraphicFramePr>
@@ -27131,6 +27871,10 @@
           </a:solidFill>
           <a:ln/>
         </p:spPr>
+        <p:txBody>
+          <a:bodyPr/>
+          <a:p/>
+        </p:txBody>
       </p:sp>
       <p:sp>
         <p:nvSpPr>
@@ -27151,6 +27895,10 @@
           </a:solidFill>
           <a:ln/>
         </p:spPr>
+        <p:txBody>
+          <a:bodyPr/>
+          <a:p/>
+        </p:txBody>
       </p:sp>
       <p:sp>
         <p:nvSpPr>
@@ -27364,6 +28112,10 @@
           </a:solidFill>
           <a:ln/>
         </p:spPr>
+        <p:txBody>
+          <a:bodyPr/>
+          <a:p/>
+        </p:txBody>
       </p:sp>
       <p:sp>
         <p:nvSpPr>
@@ -27384,6 +28136,10 @@
           </a:solidFill>
           <a:ln/>
         </p:spPr>
+        <p:txBody>
+          <a:bodyPr/>
+          <a:p/>
+        </p:txBody>
       </p:sp>
       <p:sp>
         <p:nvSpPr>
@@ -27404,6 +28160,10 @@
           </a:solidFill>
           <a:ln/>
         </p:spPr>
+        <p:txBody>
+          <a:bodyPr/>
+          <a:p/>
+        </p:txBody>
       </p:sp>
       <p:sp>
         <p:nvSpPr>
@@ -27817,6 +28577,10 @@
           </a:solidFill>
           <a:ln/>
         </p:spPr>
+        <p:txBody>
+          <a:bodyPr/>
+          <a:p/>
+        </p:txBody>
       </p:sp>
       <p:sp>
         <p:nvSpPr>
@@ -27837,6 +28601,10 @@
           </a:solidFill>
           <a:ln/>
         </p:spPr>
+        <p:txBody>
+          <a:bodyPr/>
+          <a:p/>
+        </p:txBody>
       </p:sp>
       <p:sp>
         <p:nvSpPr>
@@ -28050,6 +28818,10 @@
           </a:solidFill>
           <a:ln/>
         </p:spPr>
+        <p:txBody>
+          <a:bodyPr/>
+          <a:p/>
+        </p:txBody>
       </p:sp>
       <p:sp>
         <p:nvSpPr>
@@ -28070,6 +28842,10 @@
           </a:solidFill>
           <a:ln/>
         </p:spPr>
+        <p:txBody>
+          <a:bodyPr/>
+          <a:p/>
+        </p:txBody>
       </p:sp>
       <p:sp>
         <p:nvSpPr>
@@ -28090,6 +28866,10 @@
           </a:solidFill>
           <a:ln/>
         </p:spPr>
+        <p:txBody>
+          <a:bodyPr/>
+          <a:p/>
+        </p:txBody>
       </p:sp>
       <p:sp>
         <p:nvSpPr>
@@ -28182,6 +28962,10 @@
           </a:solidFill>
           <a:ln/>
         </p:spPr>
+        <p:txBody>
+          <a:bodyPr/>
+          <a:p/>
+        </p:txBody>
       </p:sp>
       <p:sp>
         <p:nvSpPr>
@@ -28202,6 +28986,10 @@
           </a:solidFill>
           <a:ln/>
         </p:spPr>
+        <p:txBody>
+          <a:bodyPr/>
+          <a:p/>
+        </p:txBody>
       </p:sp>
       <p:sp>
         <p:nvSpPr>
@@ -28294,6 +29082,10 @@
           </a:solidFill>
           <a:ln/>
         </p:spPr>
+        <p:txBody>
+          <a:bodyPr/>
+          <a:p/>
+        </p:txBody>
       </p:sp>
       <p:sp>
         <p:nvSpPr>
@@ -28314,6 +29106,10 @@
           </a:solidFill>
           <a:ln/>
         </p:spPr>
+        <p:txBody>
+          <a:bodyPr/>
+          <a:p/>
+        </p:txBody>
       </p:sp>
       <p:sp>
         <p:nvSpPr>
@@ -28406,6 +29202,10 @@
           </a:solidFill>
           <a:ln/>
         </p:spPr>
+        <p:txBody>
+          <a:bodyPr/>
+          <a:p/>
+        </p:txBody>
       </p:sp>
       <p:sp>
         <p:nvSpPr>
@@ -28426,6 +29226,10 @@
           </a:solidFill>
           <a:ln/>
         </p:spPr>
+        <p:txBody>
+          <a:bodyPr/>
+          <a:p/>
+        </p:txBody>
       </p:sp>
       <p:sp>
         <p:nvSpPr>
@@ -28633,6 +29437,10 @@
           </a:solidFill>
           <a:ln/>
         </p:spPr>
+        <p:txBody>
+          <a:bodyPr/>
+          <a:p/>
+        </p:txBody>
       </p:sp>
       <p:sp>
         <p:nvSpPr>
@@ -28653,6 +29461,10 @@
           </a:solidFill>
           <a:ln/>
         </p:spPr>
+        <p:txBody>
+          <a:bodyPr/>
+          <a:p/>
+        </p:txBody>
       </p:sp>
       <p:sp>
         <p:nvSpPr>
@@ -28831,6 +29643,10 @@
             <a:prstDash val="solid"/>
           </a:ln>
         </p:spPr>
+        <p:txBody>
+          <a:bodyPr/>
+          <a:p/>
+        </p:txBody>
       </p:sp>
       <p:sp>
         <p:nvSpPr>
@@ -28856,6 +29672,10 @@
             <a:prstDash val="solid"/>
           </a:ln>
         </p:spPr>
+        <p:txBody>
+          <a:bodyPr/>
+          <a:p/>
+        </p:txBody>
       </p:sp>
       <p:sp>
         <p:nvSpPr>
@@ -28881,6 +29701,10 @@
             <a:prstDash val="solid"/>
           </a:ln>
         </p:spPr>
+        <p:txBody>
+          <a:bodyPr/>
+          <a:p/>
+        </p:txBody>
       </p:sp>
       <p:sp>
         <p:nvSpPr>
@@ -28901,6 +29725,10 @@
           </a:solidFill>
           <a:ln/>
         </p:spPr>
+        <p:txBody>
+          <a:bodyPr/>
+          <a:p/>
+        </p:txBody>
       </p:sp>
       <p:sp>
         <p:nvSpPr>
@@ -29139,6 +29967,10 @@
           </a:solidFill>
           <a:ln/>
         </p:spPr>
+        <p:txBody>
+          <a:bodyPr/>
+          <a:p/>
+        </p:txBody>
       </p:sp>
       <p:sp>
         <p:nvSpPr>
@@ -29159,6 +29991,10 @@
           </a:solidFill>
           <a:ln/>
         </p:spPr>
+        <p:txBody>
+          <a:bodyPr/>
+          <a:p/>
+        </p:txBody>
       </p:sp>
       <p:sp>
         <p:nvSpPr>
@@ -31017,6 +31853,10 @@
           </a:solidFill>
           <a:ln/>
         </p:spPr>
+        <p:txBody>
+          <a:bodyPr/>
+          <a:p/>
+        </p:txBody>
       </p:sp>
       <p:sp>
         <p:nvSpPr>
@@ -31037,6 +31877,10 @@
           </a:solidFill>
           <a:ln/>
         </p:spPr>
+        <p:txBody>
+          <a:bodyPr/>
+          <a:p/>
+        </p:txBody>
       </p:sp>
       <p:sp>
         <p:nvSpPr>
@@ -31129,6 +31973,10 @@
           </a:solidFill>
           <a:ln/>
         </p:spPr>
+        <p:txBody>
+          <a:bodyPr/>
+          <a:p/>
+        </p:txBody>
       </p:sp>
       <p:sp>
         <p:nvSpPr>
@@ -31149,6 +31997,10 @@
           </a:solidFill>
           <a:ln/>
         </p:spPr>
+        <p:txBody>
+          <a:bodyPr/>
+          <a:p/>
+        </p:txBody>
       </p:sp>
       <p:sp>
         <p:nvSpPr>
@@ -31241,6 +32093,10 @@
           </a:solidFill>
           <a:ln/>
         </p:spPr>
+        <p:txBody>
+          <a:bodyPr/>
+          <a:p/>
+        </p:txBody>
       </p:sp>
       <p:sp>
         <p:nvSpPr>
@@ -31261,6 +32117,10 @@
           </a:solidFill>
           <a:ln/>
         </p:spPr>
+        <p:txBody>
+          <a:bodyPr/>
+          <a:p/>
+        </p:txBody>
       </p:sp>
       <p:sp>
         <p:nvSpPr>
@@ -31353,6 +32213,10 @@
           </a:solidFill>
           <a:ln/>
         </p:spPr>
+        <p:txBody>
+          <a:bodyPr/>
+          <a:p/>
+        </p:txBody>
       </p:sp>
       <p:sp>
         <p:nvSpPr>
@@ -31373,6 +32237,10 @@
           </a:solidFill>
           <a:ln/>
         </p:spPr>
+        <p:txBody>
+          <a:bodyPr/>
+          <a:p/>
+        </p:txBody>
       </p:sp>
       <p:sp>
         <p:nvSpPr>
@@ -31586,6 +32454,10 @@
           </a:solidFill>
           <a:ln/>
         </p:spPr>
+        <p:txBody>
+          <a:bodyPr/>
+          <a:p/>
+        </p:txBody>
       </p:sp>
       <p:sp>
         <p:nvSpPr>
@@ -31606,6 +32478,10 @@
           </a:solidFill>
           <a:ln/>
         </p:spPr>
+        <p:txBody>
+          <a:bodyPr/>
+          <a:p/>
+        </p:txBody>
       </p:sp>
       <p:sp>
         <p:nvSpPr>
@@ -31626,6 +32502,10 @@
           </a:solidFill>
           <a:ln/>
         </p:spPr>
+        <p:txBody>
+          <a:bodyPr/>
+          <a:p/>
+        </p:txBody>
       </p:sp>
       <p:sp>
         <p:nvSpPr>
@@ -31718,6 +32598,10 @@
           </a:solidFill>
           <a:ln/>
         </p:spPr>
+        <p:txBody>
+          <a:bodyPr/>
+          <a:p/>
+        </p:txBody>
       </p:sp>
       <p:sp>
         <p:nvSpPr>
@@ -31738,6 +32622,10 @@
           </a:solidFill>
           <a:ln/>
         </p:spPr>
+        <p:txBody>
+          <a:bodyPr/>
+          <a:p/>
+        </p:txBody>
       </p:sp>
       <p:sp>
         <p:nvSpPr>
@@ -31830,6 +32718,10 @@
           </a:solidFill>
           <a:ln/>
         </p:spPr>
+        <p:txBody>
+          <a:bodyPr/>
+          <a:p/>
+        </p:txBody>
       </p:sp>
       <p:sp>
         <p:nvSpPr>
@@ -31850,6 +32742,10 @@
           </a:solidFill>
           <a:ln/>
         </p:spPr>
+        <p:txBody>
+          <a:bodyPr/>
+          <a:p/>
+        </p:txBody>
       </p:sp>
       <p:sp>
         <p:nvSpPr>
@@ -31942,6 +32838,10 @@
           </a:solidFill>
           <a:ln/>
         </p:spPr>
+        <p:txBody>
+          <a:bodyPr/>
+          <a:p/>
+        </p:txBody>
       </p:sp>
       <p:sp>
         <p:nvSpPr>
@@ -31962,6 +32862,10 @@
           </a:solidFill>
           <a:ln/>
         </p:spPr>
+        <p:txBody>
+          <a:bodyPr/>
+          <a:p/>
+        </p:txBody>
       </p:sp>
       <p:sp>
         <p:nvSpPr>
@@ -32315,6 +33219,10 @@
           </a:solidFill>
           <a:ln/>
         </p:spPr>
+        <p:txBody>
+          <a:bodyPr/>
+          <a:p/>
+        </p:txBody>
       </p:sp>
       <p:sp>
         <p:nvSpPr>
@@ -32481,6 +33389,10 @@
           </a:solidFill>
           <a:ln/>
         </p:spPr>
+        <p:txBody>
+          <a:bodyPr/>
+          <a:p/>
+        </p:txBody>
       </p:sp>
       <p:sp>
         <p:nvSpPr>
@@ -32501,6 +33413,10 @@
           </a:solidFill>
           <a:ln/>
         </p:spPr>
+        <p:txBody>
+          <a:bodyPr/>
+          <a:p/>
+        </p:txBody>
       </p:sp>
       <p:sp>
         <p:nvSpPr>
@@ -32714,6 +33630,10 @@
           </a:solidFill>
           <a:ln/>
         </p:spPr>
+        <p:txBody>
+          <a:bodyPr/>
+          <a:p/>
+        </p:txBody>
       </p:sp>
       <p:graphicFrame>
         <p:nvGraphicFramePr>
@@ -33605,6 +34525,10 @@
           </a:solidFill>
           <a:ln/>
         </p:spPr>
+        <p:txBody>
+          <a:bodyPr/>
+          <a:p/>
+        </p:txBody>
       </p:sp>
       <p:sp>
         <p:nvSpPr>
@@ -33625,6 +34549,10 @@
           </a:solidFill>
           <a:ln/>
         </p:spPr>
+        <p:txBody>
+          <a:bodyPr/>
+          <a:p/>
+        </p:txBody>
       </p:sp>
       <p:sp>
         <p:nvSpPr>
@@ -33838,6 +34766,10 @@
           </a:solidFill>
           <a:ln/>
         </p:spPr>
+        <p:txBody>
+          <a:bodyPr/>
+          <a:p/>
+        </p:txBody>
       </p:sp>
       <p:sp>
         <p:nvSpPr>
@@ -33858,6 +34790,10 @@
           </a:solidFill>
           <a:ln/>
         </p:spPr>
+        <p:txBody>
+          <a:bodyPr/>
+          <a:p/>
+        </p:txBody>
       </p:sp>
       <p:sp>
         <p:nvSpPr>
@@ -33878,6 +34814,10 @@
           </a:solidFill>
           <a:ln/>
         </p:spPr>
+        <p:txBody>
+          <a:bodyPr/>
+          <a:p/>
+        </p:txBody>
       </p:sp>
       <p:sp>
         <p:nvSpPr>
@@ -33970,6 +34910,10 @@
           </a:solidFill>
           <a:ln/>
         </p:spPr>
+        <p:txBody>
+          <a:bodyPr/>
+          <a:p/>
+        </p:txBody>
       </p:sp>
       <p:sp>
         <p:nvSpPr>
@@ -33990,6 +34934,10 @@
           </a:solidFill>
           <a:ln/>
         </p:spPr>
+        <p:txBody>
+          <a:bodyPr/>
+          <a:p/>
+        </p:txBody>
       </p:sp>
       <p:sp>
         <p:nvSpPr>
@@ -34082,6 +35030,10 @@
           </a:solidFill>
           <a:ln/>
         </p:spPr>
+        <p:txBody>
+          <a:bodyPr/>
+          <a:p/>
+        </p:txBody>
       </p:sp>
       <p:sp>
         <p:nvSpPr>
@@ -34102,6 +35054,10 @@
           </a:solidFill>
           <a:ln/>
         </p:spPr>
+        <p:txBody>
+          <a:bodyPr/>
+          <a:p/>
+        </p:txBody>
       </p:sp>
       <p:sp>
         <p:nvSpPr>
@@ -34194,6 +35150,10 @@
           </a:solidFill>
           <a:ln/>
         </p:spPr>
+        <p:txBody>
+          <a:bodyPr/>
+          <a:p/>
+        </p:txBody>
       </p:sp>
       <p:sp>
         <p:nvSpPr>
@@ -34214,6 +35174,10 @@
           </a:solidFill>
           <a:ln/>
         </p:spPr>
+        <p:txBody>
+          <a:bodyPr/>
+          <a:p/>
+        </p:txBody>
       </p:sp>
       <p:sp>
         <p:nvSpPr>
@@ -35568,6 +36532,10 @@
           </a:solidFill>
           <a:ln/>
         </p:spPr>
+        <p:txBody>
+          <a:bodyPr/>
+          <a:p/>
+        </p:txBody>
       </p:sp>
       <p:sp>
         <p:nvSpPr>
@@ -35588,6 +36556,10 @@
           </a:solidFill>
           <a:ln/>
         </p:spPr>
+        <p:txBody>
+          <a:bodyPr/>
+          <a:p/>
+        </p:txBody>
       </p:sp>
       <p:sp>
         <p:nvSpPr>
@@ -35801,6 +36773,10 @@
           </a:solidFill>
           <a:ln/>
         </p:spPr>
+        <p:txBody>
+          <a:bodyPr/>
+          <a:p/>
+        </p:txBody>
       </p:sp>
       <p:sp>
         <p:nvSpPr>
@@ -35821,6 +36797,10 @@
           </a:solidFill>
           <a:ln/>
         </p:spPr>
+        <p:txBody>
+          <a:bodyPr/>
+          <a:p/>
+        </p:txBody>
       </p:sp>
       <p:sp>
         <p:nvSpPr>
@@ -35841,6 +36821,10 @@
           </a:solidFill>
           <a:ln/>
         </p:spPr>
+        <p:txBody>
+          <a:bodyPr/>
+          <a:p/>
+        </p:txBody>
       </p:sp>
       <p:sp>
         <p:nvSpPr>
@@ -35933,6 +36917,10 @@
           </a:solidFill>
           <a:ln/>
         </p:spPr>
+        <p:txBody>
+          <a:bodyPr/>
+          <a:p/>
+        </p:txBody>
       </p:sp>
       <p:sp>
         <p:nvSpPr>
@@ -35953,6 +36941,10 @@
           </a:solidFill>
           <a:ln/>
         </p:spPr>
+        <p:txBody>
+          <a:bodyPr/>
+          <a:p/>
+        </p:txBody>
       </p:sp>
       <p:sp>
         <p:nvSpPr>
@@ -36045,6 +37037,10 @@
           </a:solidFill>
           <a:ln/>
         </p:spPr>
+        <p:txBody>
+          <a:bodyPr/>
+          <a:p/>
+        </p:txBody>
       </p:sp>
       <p:sp>
         <p:nvSpPr>
@@ -36065,6 +37061,10 @@
           </a:solidFill>
           <a:ln/>
         </p:spPr>
+        <p:txBody>
+          <a:bodyPr/>
+          <a:p/>
+        </p:txBody>
       </p:sp>
       <p:sp>
         <p:nvSpPr>
@@ -36157,6 +37157,10 @@
           </a:solidFill>
           <a:ln/>
         </p:spPr>
+        <p:txBody>
+          <a:bodyPr/>
+          <a:p/>
+        </p:txBody>
       </p:sp>
       <p:sp>
         <p:nvSpPr>
@@ -36177,6 +37181,10 @@
           </a:solidFill>
           <a:ln/>
         </p:spPr>
+        <p:txBody>
+          <a:bodyPr/>
+          <a:p/>
+        </p:txBody>
       </p:sp>
       <p:sp>
         <p:nvSpPr>
@@ -37531,6 +38539,10 @@
           </a:solidFill>
           <a:ln/>
         </p:spPr>
+        <p:txBody>
+          <a:bodyPr/>
+          <a:p/>
+        </p:txBody>
       </p:sp>
       <p:sp>
         <p:nvSpPr>
@@ -37551,6 +38563,10 @@
           </a:solidFill>
           <a:ln/>
         </p:spPr>
+        <p:txBody>
+          <a:bodyPr/>
+          <a:p/>
+        </p:txBody>
       </p:sp>
       <p:sp>
         <p:nvSpPr>
@@ -37764,6 +38780,10 @@
           </a:solidFill>
           <a:ln/>
         </p:spPr>
+        <p:txBody>
+          <a:bodyPr/>
+          <a:p/>
+        </p:txBody>
       </p:sp>
       <p:sp>
         <p:nvSpPr>
@@ -37796,6 +38816,10 @@
             </a:outerShdw>
           </a:effectLst>
         </p:spPr>
+        <p:txBody>
+          <a:bodyPr/>
+          <a:p/>
+        </p:txBody>
       </p:sp>
       <p:sp>
         <p:nvSpPr>
@@ -37900,6 +38924,10 @@
             </a:outerShdw>
           </a:effectLst>
         </p:spPr>
+        <p:txBody>
+          <a:bodyPr/>
+          <a:p/>
+        </p:txBody>
       </p:sp>
       <p:sp>
         <p:nvSpPr>
@@ -37996,6 +39024,10 @@
             <a:tailEnd type="triangle"/>
           </a:ln>
         </p:spPr>
+        <p:txBody>
+          <a:bodyPr/>
+          <a:p/>
+        </p:txBody>
       </p:sp>
       <p:sp>
         <p:nvSpPr>
@@ -38028,6 +39060,10 @@
             </a:outerShdw>
           </a:effectLst>
         </p:spPr>
+        <p:txBody>
+          <a:bodyPr/>
+          <a:p/>
+        </p:txBody>
       </p:sp>
       <p:sp>
         <p:nvSpPr>
@@ -38124,6 +39160,10 @@
             <a:tailEnd type="triangle"/>
           </a:ln>
         </p:spPr>
+        <p:txBody>
+          <a:bodyPr/>
+          <a:p/>
+        </p:txBody>
       </p:sp>
       <p:sp>
         <p:nvSpPr>
@@ -38156,6 +39196,10 @@
             </a:outerShdw>
           </a:effectLst>
         </p:spPr>
+        <p:txBody>
+          <a:bodyPr/>
+          <a:p/>
+        </p:txBody>
       </p:sp>
       <p:sp>
         <p:nvSpPr>
@@ -38252,6 +39296,10 @@
             <a:tailEnd type="triangle"/>
           </a:ln>
         </p:spPr>
+        <p:txBody>
+          <a:bodyPr/>
+          <a:p/>
+        </p:txBody>
       </p:sp>
       <p:sp>
         <p:nvSpPr>
@@ -38284,6 +39332,10 @@
             </a:outerShdw>
           </a:effectLst>
         </p:spPr>
+        <p:txBody>
+          <a:bodyPr/>
+          <a:p/>
+        </p:txBody>
       </p:sp>
       <p:sp>
         <p:nvSpPr>
@@ -38380,6 +39432,10 @@
             <a:tailEnd type="triangle"/>
           </a:ln>
         </p:spPr>
+        <p:txBody>
+          <a:bodyPr/>
+          <a:p/>
+        </p:txBody>
       </p:sp>
       <p:sp>
         <p:nvSpPr>
@@ -38412,6 +39468,10 @@
             </a:outerShdw>
           </a:effectLst>
         </p:spPr>
+        <p:txBody>
+          <a:bodyPr/>
+          <a:p/>
+        </p:txBody>
       </p:sp>
       <p:sp>
         <p:nvSpPr>
@@ -38508,6 +39568,10 @@
             <a:tailEnd type="triangle"/>
           </a:ln>
         </p:spPr>
+        <p:txBody>
+          <a:bodyPr/>
+          <a:p/>
+        </p:txBody>
       </p:sp>
       <p:sp>
         <p:nvSpPr>
@@ -38528,6 +39592,10 @@
           </a:solidFill>
           <a:ln/>
         </p:spPr>
+        <p:txBody>
+          <a:bodyPr/>
+          <a:p/>
+        </p:txBody>
       </p:sp>
       <p:sp>
         <p:nvSpPr>
@@ -38548,6 +39616,10 @@
           </a:solidFill>
           <a:ln/>
         </p:spPr>
+        <p:txBody>
+          <a:bodyPr/>
+          <a:p/>
+        </p:txBody>
       </p:sp>
       <p:sp>
         <p:nvSpPr>
@@ -38640,6 +39712,10 @@
           </a:solidFill>
           <a:ln/>
         </p:spPr>
+        <p:txBody>
+          <a:bodyPr/>
+          <a:p/>
+        </p:txBody>
       </p:sp>
       <p:sp>
         <p:nvSpPr>
@@ -38660,6 +39736,10 @@
           </a:solidFill>
           <a:ln/>
         </p:spPr>
+        <p:txBody>
+          <a:bodyPr/>
+          <a:p/>
+        </p:txBody>
       </p:sp>
       <p:sp>
         <p:nvSpPr>
@@ -38752,6 +39832,10 @@
           </a:solidFill>
           <a:ln/>
         </p:spPr>
+        <p:txBody>
+          <a:bodyPr/>
+          <a:p/>
+        </p:txBody>
       </p:sp>
       <p:sp>
         <p:nvSpPr>
@@ -38772,6 +39856,10 @@
           </a:solidFill>
           <a:ln/>
         </p:spPr>
+        <p:txBody>
+          <a:bodyPr/>
+          <a:p/>
+        </p:txBody>
       </p:sp>
       <p:sp>
         <p:nvSpPr>
@@ -38864,6 +39952,10 @@
           </a:solidFill>
           <a:ln/>
         </p:spPr>
+        <p:txBody>
+          <a:bodyPr/>
+          <a:p/>
+        </p:txBody>
       </p:sp>
       <p:sp>
         <p:nvSpPr>
@@ -38884,6 +39976,10 @@
           </a:solidFill>
           <a:ln/>
         </p:spPr>
+        <p:txBody>
+          <a:bodyPr/>
+          <a:p/>
+        </p:txBody>
       </p:sp>
       <p:sp>
         <p:nvSpPr>
@@ -39227,7 +40323,7 @@
                   <a:srgbClr val="4A5058"/>
                 </a:solidFill>
               </a:rPr>
-              <a:t>Plus 18 source plugins, a server, integration tests and benchmarks.</a:t>
+              <a:t>Plus 19 source plugins, a server, integration tests and benchmarks.</a:t>
             </a:r>
             <a:endParaRPr lang="en-US" sz="1500" dirty="0"/>
           </a:p>
@@ -39363,6 +40459,10 @@
             <a:prstDash val="solid"/>
           </a:ln>
         </p:spPr>
+        <p:txBody>
+          <a:bodyPr/>
+          <a:p/>
+        </p:txBody>
       </p:sp>
       <p:sp>
         <p:nvSpPr>
@@ -39388,6 +40488,10 @@
             <a:prstDash val="solid"/>
           </a:ln>
         </p:spPr>
+        <p:txBody>
+          <a:bodyPr/>
+          <a:p/>
+        </p:txBody>
       </p:sp>
       <p:sp>
         <p:nvSpPr>
@@ -39413,6 +40517,10 @@
             <a:prstDash val="solid"/>
           </a:ln>
         </p:spPr>
+        <p:txBody>
+          <a:bodyPr/>
+          <a:p/>
+        </p:txBody>
       </p:sp>
       <p:sp>
         <p:nvSpPr>
@@ -39433,6 +40541,10 @@
           </a:solidFill>
           <a:ln/>
         </p:spPr>
+        <p:txBody>
+          <a:bodyPr/>
+          <a:p/>
+        </p:txBody>
       </p:sp>
       <p:sp>
         <p:nvSpPr>
@@ -39671,6 +40783,10 @@
           </a:solidFill>
           <a:ln/>
         </p:spPr>
+        <p:txBody>
+          <a:bodyPr/>
+          <a:p/>
+        </p:txBody>
       </p:sp>
       <p:graphicFrame>
         <p:nvGraphicFramePr>
@@ -41348,6 +42464,10 @@
           </a:solidFill>
           <a:ln/>
         </p:spPr>
+        <p:txBody>
+          <a:bodyPr/>
+          <a:p/>
+        </p:txBody>
       </p:sp>
       <p:sp>
         <p:nvSpPr>
@@ -41368,6 +42488,10 @@
           </a:solidFill>
           <a:ln/>
         </p:spPr>
+        <p:txBody>
+          <a:bodyPr/>
+          <a:p/>
+        </p:txBody>
       </p:sp>
       <p:sp>
         <p:nvSpPr>
@@ -41388,6 +42512,10 @@
           </a:solidFill>
           <a:ln/>
         </p:spPr>
+        <p:txBody>
+          <a:bodyPr/>
+          <a:p/>
+        </p:txBody>
       </p:sp>
       <p:sp>
         <p:nvSpPr>
@@ -41618,6 +42746,10 @@
             </a:outerShdw>
           </a:effectLst>
         </p:spPr>
+        <p:txBody>
+          <a:bodyPr/>
+          <a:p/>
+        </p:txBody>
       </p:sp>
       <p:sp>
         <p:nvSpPr>
@@ -41722,6 +42854,10 @@
             </a:outerShdw>
           </a:effectLst>
         </p:spPr>
+        <p:txBody>
+          <a:bodyPr/>
+          <a:p/>
+        </p:txBody>
       </p:sp>
       <p:sp>
         <p:nvSpPr>
@@ -41826,6 +42962,10 @@
             </a:outerShdw>
           </a:effectLst>
         </p:spPr>
+        <p:txBody>
+          <a:bodyPr/>
+          <a:p/>
+        </p:txBody>
       </p:sp>
       <p:sp>
         <p:nvSpPr>
@@ -41930,6 +43070,10 @@
             </a:outerShdw>
           </a:effectLst>
         </p:spPr>
+        <p:txBody>
+          <a:bodyPr/>
+          <a:p/>
+        </p:txBody>
       </p:sp>
       <p:sp>
         <p:nvSpPr>
@@ -42022,6 +43166,10 @@
           </a:solidFill>
           <a:ln/>
         </p:spPr>
+        <p:txBody>
+          <a:bodyPr/>
+          <a:p/>
+        </p:txBody>
       </p:sp>
       <p:sp>
         <p:nvSpPr>
@@ -42042,6 +43190,10 @@
           </a:solidFill>
           <a:ln/>
         </p:spPr>
+        <p:txBody>
+          <a:bodyPr/>
+          <a:p/>
+        </p:txBody>
       </p:sp>
       <p:sp>
         <p:nvSpPr>
@@ -42184,6 +43336,10 @@
             <a:prstDash val="solid"/>
           </a:ln>
         </p:spPr>
+        <p:txBody>
+          <a:bodyPr/>
+          <a:p/>
+        </p:txBody>
       </p:sp>
       <p:sp>
         <p:nvSpPr>
@@ -42209,6 +43365,10 @@
             <a:prstDash val="solid"/>
           </a:ln>
         </p:spPr>
+        <p:txBody>
+          <a:bodyPr/>
+          <a:p/>
+        </p:txBody>
       </p:sp>
       <p:sp>
         <p:nvSpPr>
@@ -42234,6 +43394,10 @@
             <a:prstDash val="solid"/>
           </a:ln>
         </p:spPr>
+        <p:txBody>
+          <a:bodyPr/>
+          <a:p/>
+        </p:txBody>
       </p:sp>
       <p:sp>
         <p:nvSpPr>
@@ -42290,6 +43454,10 @@
           </a:solidFill>
           <a:ln/>
         </p:spPr>
+        <p:txBody>
+          <a:bodyPr/>
+          <a:p/>
+        </p:txBody>
       </p:sp>
       <p:sp>
         <p:nvSpPr>
@@ -42528,6 +43696,10 @@
           </a:solidFill>
           <a:ln/>
         </p:spPr>
+        <p:txBody>
+          <a:bodyPr/>
+          <a:p/>
+        </p:txBody>
       </p:sp>
       <p:sp>
         <p:nvSpPr>
@@ -42548,6 +43720,10 @@
           </a:solidFill>
           <a:ln/>
         </p:spPr>
+        <p:txBody>
+          <a:bodyPr/>
+          <a:p/>
+        </p:txBody>
       </p:sp>
       <p:sp>
         <p:nvSpPr>
@@ -42719,6 +43895,10 @@
           </a:solidFill>
           <a:ln/>
         </p:spPr>
+        <p:txBody>
+          <a:bodyPr/>
+          <a:p/>
+        </p:txBody>
       </p:sp>
       <p:sp>
         <p:nvSpPr>
@@ -42890,6 +44070,10 @@
           </a:solidFill>
           <a:ln/>
         </p:spPr>
+        <p:txBody>
+          <a:bodyPr/>
+          <a:p/>
+        </p:txBody>
       </p:sp>
       <p:sp>
         <p:nvSpPr>
@@ -42910,6 +44094,10 @@
           </a:solidFill>
           <a:ln/>
         </p:spPr>
+        <p:txBody>
+          <a:bodyPr/>
+          <a:p/>
+        </p:txBody>
       </p:sp>
       <p:sp>
         <p:nvSpPr>
@@ -43123,6 +44311,10 @@
           </a:solidFill>
           <a:ln/>
         </p:spPr>
+        <p:txBody>
+          <a:bodyPr/>
+          <a:p/>
+        </p:txBody>
       </p:sp>
       <p:sp>
         <p:nvSpPr>
@@ -43155,6 +44347,10 @@
             </a:outerShdw>
           </a:effectLst>
         </p:spPr>
+        <p:txBody>
+          <a:bodyPr/>
+          <a:p/>
+        </p:txBody>
       </p:sp>
       <p:sp>
         <p:nvSpPr>
@@ -43259,6 +44455,10 @@
             </a:outerShdw>
           </a:effectLst>
         </p:spPr>
+        <p:txBody>
+          <a:bodyPr/>
+          <a:p/>
+        </p:txBody>
       </p:sp>
       <p:sp>
         <p:nvSpPr>
@@ -43363,6 +44563,10 @@
             </a:outerShdw>
           </a:effectLst>
         </p:spPr>
+        <p:txBody>
+          <a:bodyPr/>
+          <a:p/>
+        </p:txBody>
       </p:sp>
       <p:sp>
         <p:nvSpPr>
@@ -43467,6 +44671,10 @@
             </a:outerShdw>
           </a:effectLst>
         </p:spPr>
+        <p:txBody>
+          <a:bodyPr/>
+          <a:p/>
+        </p:txBody>
       </p:sp>
       <p:sp>
         <p:nvSpPr>
@@ -43563,6 +44771,10 @@
             <a:tailEnd type="triangle"/>
           </a:ln>
         </p:spPr>
+        <p:txBody>
+          <a:bodyPr/>
+          <a:p/>
+        </p:txBody>
       </p:sp>
       <p:sp>
         <p:nvSpPr>
@@ -43587,6 +44799,10 @@
             <a:tailEnd type="triangle"/>
           </a:ln>
         </p:spPr>
+        <p:txBody>
+          <a:bodyPr/>
+          <a:p/>
+        </p:txBody>
       </p:sp>
       <p:sp>
         <p:nvSpPr>
@@ -43611,6 +44827,10 @@
             <a:tailEnd type="triangle"/>
           </a:ln>
         </p:spPr>
+        <p:txBody>
+          <a:bodyPr/>
+          <a:p/>
+        </p:txBody>
       </p:sp>
       <p:sp>
         <p:nvSpPr>
@@ -43643,6 +44863,10 @@
             </a:outerShdw>
           </a:effectLst>
         </p:spPr>
+        <p:txBody>
+          <a:bodyPr/>
+          <a:p/>
+        </p:txBody>
       </p:sp>
       <p:sp>
         <p:nvSpPr>
@@ -43747,6 +44971,10 @@
             </a:outerShdw>
           </a:effectLst>
         </p:spPr>
+        <p:txBody>
+          <a:bodyPr/>
+          <a:p/>
+        </p:txBody>
       </p:sp>
       <p:sp>
         <p:nvSpPr>
@@ -43887,6 +45115,10 @@
             </a:outerShdw>
           </a:effectLst>
         </p:spPr>
+        <p:txBody>
+          <a:bodyPr/>
+          <a:p/>
+        </p:txBody>
       </p:sp>
       <p:sp>
         <p:nvSpPr>
@@ -43983,6 +45215,10 @@
             <a:tailEnd type="triangle"/>
           </a:ln>
         </p:spPr>
+        <p:txBody>
+          <a:bodyPr/>
+          <a:p/>
+        </p:txBody>
       </p:sp>
       <p:sp>
         <p:nvSpPr>
@@ -44007,6 +45243,10 @@
             <a:tailEnd type="triangle"/>
           </a:ln>
         </p:spPr>
+        <p:txBody>
+          <a:bodyPr/>
+          <a:p/>
+        </p:txBody>
       </p:sp>
       <p:sp>
         <p:nvSpPr>
@@ -44027,6 +45267,10 @@
           </a:solidFill>
           <a:ln/>
         </p:spPr>
+        <p:txBody>
+          <a:bodyPr/>
+          <a:p/>
+        </p:txBody>
       </p:sp>
       <p:sp>
         <p:nvSpPr>
@@ -44047,6 +45291,10 @@
           </a:solidFill>
           <a:ln/>
         </p:spPr>
+        <p:txBody>
+          <a:bodyPr/>
+          <a:p/>
+        </p:txBody>
       </p:sp>
       <p:sp>
         <p:nvSpPr>
@@ -44260,6 +45508,10 @@
           </a:solidFill>
           <a:ln/>
         </p:spPr>
+        <p:txBody>
+          <a:bodyPr/>
+          <a:p/>
+        </p:txBody>
       </p:sp>
       <p:sp>
         <p:nvSpPr>
@@ -44280,6 +45532,10 @@
           </a:solidFill>
           <a:ln/>
         </p:spPr>
+        <p:txBody>
+          <a:bodyPr/>
+          <a:p/>
+        </p:txBody>
       </p:sp>
       <p:sp>
         <p:nvSpPr>
@@ -44408,6 +45664,10 @@
           </a:solidFill>
           <a:ln/>
         </p:spPr>
+        <p:txBody>
+          <a:bodyPr/>
+          <a:p/>
+        </p:txBody>
       </p:sp>
       <p:sp>
         <p:nvSpPr>
@@ -44536,6 +45796,10 @@
           </a:solidFill>
           <a:ln/>
         </p:spPr>
+        <p:txBody>
+          <a:bodyPr/>
+          <a:p/>
+        </p:txBody>
       </p:sp>
       <p:sp>
         <p:nvSpPr>
@@ -44664,6 +45928,10 @@
           </a:solidFill>
           <a:ln/>
         </p:spPr>
+        <p:txBody>
+          <a:bodyPr/>
+          <a:p/>
+        </p:txBody>
       </p:sp>
       <p:sp>
         <p:nvSpPr>
@@ -44792,6 +46060,10 @@
           </a:solidFill>
           <a:ln/>
         </p:spPr>
+        <p:txBody>
+          <a:bodyPr/>
+          <a:p/>
+        </p:txBody>
       </p:sp>
       <p:sp>
         <p:nvSpPr>
@@ -44920,6 +46192,10 @@
           </a:solidFill>
           <a:ln/>
         </p:spPr>
+        <p:txBody>
+          <a:bodyPr/>
+          <a:p/>
+        </p:txBody>
       </p:sp>
       <p:sp>
         <p:nvSpPr>
@@ -45048,6 +46324,10 @@
           </a:solidFill>
           <a:ln/>
         </p:spPr>
+        <p:txBody>
+          <a:bodyPr/>
+          <a:p/>
+        </p:txBody>
       </p:sp>
       <p:sp>
         <p:nvSpPr>
@@ -45068,6 +46348,10 @@
           </a:solidFill>
           <a:ln/>
         </p:spPr>
+        <p:txBody>
+          <a:bodyPr/>
+          <a:p/>
+        </p:txBody>
       </p:sp>
       <p:sp>
         <p:nvSpPr>
@@ -45281,6 +46565,10 @@
           </a:solidFill>
           <a:ln/>
         </p:spPr>
+        <p:txBody>
+          <a:bodyPr/>
+          <a:p/>
+        </p:txBody>
       </p:sp>
       <p:graphicFrame>
         <p:nvGraphicFramePr>
@@ -46563,6 +47851,10 @@
           </a:solidFill>
           <a:ln/>
         </p:spPr>
+        <p:txBody>
+          <a:bodyPr/>
+          <a:p/>
+        </p:txBody>
       </p:sp>
       <p:sp>
         <p:nvSpPr>
@@ -46583,6 +47875,10 @@
           </a:solidFill>
           <a:ln/>
         </p:spPr>
+        <p:txBody>
+          <a:bodyPr/>
+          <a:p/>
+        </p:txBody>
       </p:sp>
       <p:sp>
         <p:nvSpPr>
@@ -46796,6 +48092,10 @@
           </a:solidFill>
           <a:ln/>
         </p:spPr>
+        <p:txBody>
+          <a:bodyPr/>
+          <a:p/>
+        </p:txBody>
       </p:sp>
       <p:graphicFrame>
         <p:nvGraphicFramePr>

</xml_diff>